<commit_message>
Frontend- Show categories at frontend
</commit_message>
<xml_diff>
--- a/.lessons/56 Category, Subcategory and Child Category Setup/20 Frontend- Show categories at frontend/1.pptx
+++ b/.lessons/56 Category, Subcategory and Child Category Setup/20 Frontend- Show categories at frontend/1.pptx
@@ -7,7 +7,21 @@
   <p:sldIdLst>
     <p:sldId id="413" r:id="rId2"/>
     <p:sldId id="414" r:id="rId3"/>
-    <p:sldId id="400" r:id="rId4"/>
+    <p:sldId id="415" r:id="rId4"/>
+    <p:sldId id="416" r:id="rId5"/>
+    <p:sldId id="417" r:id="rId6"/>
+    <p:sldId id="418" r:id="rId7"/>
+    <p:sldId id="419" r:id="rId8"/>
+    <p:sldId id="400" r:id="rId9"/>
+    <p:sldId id="420" r:id="rId10"/>
+    <p:sldId id="421" r:id="rId11"/>
+    <p:sldId id="422" r:id="rId12"/>
+    <p:sldId id="423" r:id="rId13"/>
+    <p:sldId id="424" r:id="rId14"/>
+    <p:sldId id="425" r:id="rId15"/>
+    <p:sldId id="426" r:id="rId16"/>
+    <p:sldId id="427" r:id="rId17"/>
+    <p:sldId id="428" r:id="rId18"/>
   </p:sldIdLst>
   <p:sldSz cx="12192000" cy="6858000"/>
   <p:notesSz cx="6858000" cy="9144000"/>
@@ -261,7 +275,7 @@
           <a:p>
             <a:fld id="{3E102D2E-813C-461C-9963-687A650C48C0}" type="datetimeFigureOut">
               <a:rPr lang="en-US" smtClean="0"/>
-              <a:t>6/26/2025</a:t>
+              <a:t>8/29/2025</a:t>
             </a:fld>
             <a:endParaRPr lang="en-US"/>
           </a:p>
@@ -459,7 +473,7 @@
           <a:p>
             <a:fld id="{3E102D2E-813C-461C-9963-687A650C48C0}" type="datetimeFigureOut">
               <a:rPr lang="en-US" smtClean="0"/>
-              <a:t>6/26/2025</a:t>
+              <a:t>8/29/2025</a:t>
             </a:fld>
             <a:endParaRPr lang="en-US"/>
           </a:p>
@@ -667,7 +681,7 @@
           <a:p>
             <a:fld id="{3E102D2E-813C-461C-9963-687A650C48C0}" type="datetimeFigureOut">
               <a:rPr lang="en-US" smtClean="0"/>
-              <a:t>6/26/2025</a:t>
+              <a:t>8/29/2025</a:t>
             </a:fld>
             <a:endParaRPr lang="en-US"/>
           </a:p>
@@ -865,7 +879,7 @@
           <a:p>
             <a:fld id="{3E102D2E-813C-461C-9963-687A650C48C0}" type="datetimeFigureOut">
               <a:rPr lang="en-US" smtClean="0"/>
-              <a:t>6/26/2025</a:t>
+              <a:t>8/29/2025</a:t>
             </a:fld>
             <a:endParaRPr lang="en-US"/>
           </a:p>
@@ -1140,7 +1154,7 @@
           <a:p>
             <a:fld id="{3E102D2E-813C-461C-9963-687A650C48C0}" type="datetimeFigureOut">
               <a:rPr lang="en-US" smtClean="0"/>
-              <a:t>6/26/2025</a:t>
+              <a:t>8/29/2025</a:t>
             </a:fld>
             <a:endParaRPr lang="en-US"/>
           </a:p>
@@ -1405,7 +1419,7 @@
           <a:p>
             <a:fld id="{3E102D2E-813C-461C-9963-687A650C48C0}" type="datetimeFigureOut">
               <a:rPr lang="en-US" smtClean="0"/>
-              <a:t>6/26/2025</a:t>
+              <a:t>8/29/2025</a:t>
             </a:fld>
             <a:endParaRPr lang="en-US"/>
           </a:p>
@@ -1817,7 +1831,7 @@
           <a:p>
             <a:fld id="{3E102D2E-813C-461C-9963-687A650C48C0}" type="datetimeFigureOut">
               <a:rPr lang="en-US" smtClean="0"/>
-              <a:t>6/26/2025</a:t>
+              <a:t>8/29/2025</a:t>
             </a:fld>
             <a:endParaRPr lang="en-US"/>
           </a:p>
@@ -1958,7 +1972,7 @@
           <a:p>
             <a:fld id="{3E102D2E-813C-461C-9963-687A650C48C0}" type="datetimeFigureOut">
               <a:rPr lang="en-US" smtClean="0"/>
-              <a:t>6/26/2025</a:t>
+              <a:t>8/29/2025</a:t>
             </a:fld>
             <a:endParaRPr lang="en-US"/>
           </a:p>
@@ -2071,7 +2085,7 @@
           <a:p>
             <a:fld id="{3E102D2E-813C-461C-9963-687A650C48C0}" type="datetimeFigureOut">
               <a:rPr lang="en-US" smtClean="0"/>
-              <a:t>6/26/2025</a:t>
+              <a:t>8/29/2025</a:t>
             </a:fld>
             <a:endParaRPr lang="en-US"/>
           </a:p>
@@ -2382,7 +2396,7 @@
           <a:p>
             <a:fld id="{3E102D2E-813C-461C-9963-687A650C48C0}" type="datetimeFigureOut">
               <a:rPr lang="en-US" smtClean="0"/>
-              <a:t>6/26/2025</a:t>
+              <a:t>8/29/2025</a:t>
             </a:fld>
             <a:endParaRPr lang="en-US"/>
           </a:p>
@@ -2670,7 +2684,7 @@
           <a:p>
             <a:fld id="{3E102D2E-813C-461C-9963-687A650C48C0}" type="datetimeFigureOut">
               <a:rPr lang="en-US" smtClean="0"/>
-              <a:t>6/26/2025</a:t>
+              <a:t>8/29/2025</a:t>
             </a:fld>
             <a:endParaRPr lang="en-US"/>
           </a:p>
@@ -2911,7 +2925,7 @@
           <a:p>
             <a:fld id="{3E102D2E-813C-461C-9963-687A650C48C0}" type="datetimeFigureOut">
               <a:rPr lang="en-US" smtClean="0"/>
-              <a:t>6/26/2025</a:t>
+              <a:t>8/29/2025</a:t>
             </a:fld>
             <a:endParaRPr lang="en-US"/>
           </a:p>
@@ -3384,10 +3398,930 @@
           </a:p>
         </p:txBody>
       </p:sp>
+      <p:pic>
+        <p:nvPicPr>
+          <p:cNvPr id="4" name="Picture 3">
+            <a:extLst>
+              <a:ext uri="{FF2B5EF4-FFF2-40B4-BE49-F238E27FC236}">
+                <a16:creationId xmlns:a16="http://schemas.microsoft.com/office/drawing/2014/main" id="{8A2E1653-342D-2BB1-462D-63BB66914101}"/>
+              </a:ext>
+            </a:extLst>
+          </p:cNvPr>
+          <p:cNvPicPr>
+            <a:picLocks noChangeAspect="1"/>
+          </p:cNvPicPr>
+          <p:nvPr/>
+        </p:nvPicPr>
+        <p:blipFill>
+          <a:blip r:embed="rId2"/>
+          <a:stretch>
+            <a:fillRect/>
+          </a:stretch>
+        </p:blipFill>
+        <p:spPr>
+          <a:xfrm>
+            <a:off x="0" y="1100512"/>
+            <a:ext cx="12192000" cy="4656975"/>
+          </a:xfrm>
+          <a:prstGeom prst="rect">
+            <a:avLst/>
+          </a:prstGeom>
+          <a:ln w="38100" cap="sq">
+            <a:solidFill>
+              <a:srgbClr val="000000"/>
+            </a:solidFill>
+            <a:prstDash val="solid"/>
+            <a:miter lim="800000"/>
+          </a:ln>
+          <a:effectLst>
+            <a:outerShdw blurRad="50800" dist="38100" dir="2700000" algn="tl" rotWithShape="0">
+              <a:srgbClr val="000000">
+                <a:alpha val="43000"/>
+              </a:srgbClr>
+            </a:outerShdw>
+          </a:effectLst>
+        </p:spPr>
+      </p:pic>
     </p:spTree>
     <p:extLst>
       <p:ext uri="{BB962C8B-B14F-4D97-AF65-F5344CB8AC3E}">
         <p14:creationId xmlns:p14="http://schemas.microsoft.com/office/powerpoint/2010/main" val="3863838039"/>
+      </p:ext>
+    </p:extLst>
+  </p:cSld>
+  <p:clrMapOvr>
+    <a:masterClrMapping/>
+  </p:clrMapOvr>
+</p:sld>
+</file>
+
+<file path=ppt/slides/slide10.xml><?xml version="1.0" encoding="utf-8"?>
+<p:sld xmlns:a="http://schemas.openxmlformats.org/drawingml/2006/main" xmlns:r="http://schemas.openxmlformats.org/officeDocument/2006/relationships" xmlns:p="http://schemas.openxmlformats.org/presentationml/2006/main">
+  <p:cSld>
+    <p:spTree>
+      <p:nvGrpSpPr>
+        <p:cNvPr id="1" name="">
+          <a:extLst>
+            <a:ext uri="{FF2B5EF4-FFF2-40B4-BE49-F238E27FC236}">
+              <a16:creationId xmlns:a16="http://schemas.microsoft.com/office/drawing/2014/main" id="{F094E61C-B6BE-D6DA-1E56-80A7122493C0}"/>
+            </a:ext>
+          </a:extLst>
+        </p:cNvPr>
+        <p:cNvGrpSpPr/>
+        <p:nvPr/>
+      </p:nvGrpSpPr>
+      <p:grpSpPr>
+        <a:xfrm>
+          <a:off x="0" y="0"/>
+          <a:ext cx="0" cy="0"/>
+          <a:chOff x="0" y="0"/>
+          <a:chExt cx="0" cy="0"/>
+        </a:xfrm>
+      </p:grpSpPr>
+      <p:sp>
+        <p:nvSpPr>
+          <p:cNvPr id="3" name="TextBox 2">
+            <a:extLst>
+              <a:ext uri="{FF2B5EF4-FFF2-40B4-BE49-F238E27FC236}">
+                <a16:creationId xmlns:a16="http://schemas.microsoft.com/office/drawing/2014/main" id="{BC6177FB-35FF-3BBB-B167-9D36AA2A2C6F}"/>
+              </a:ext>
+            </a:extLst>
+          </p:cNvPr>
+          <p:cNvSpPr txBox="1"/>
+          <p:nvPr/>
+        </p:nvSpPr>
+        <p:spPr>
+          <a:xfrm>
+            <a:off x="217714" y="255046"/>
+            <a:ext cx="11756571" cy="355354"/>
+          </a:xfrm>
+          <a:prstGeom prst="rect">
+            <a:avLst/>
+          </a:prstGeom>
+          <a:noFill/>
+        </p:spPr>
+        <p:txBody>
+          <a:bodyPr wrap="square">
+            <a:spAutoFit/>
+          </a:bodyPr>
+          <a:lstStyle/>
+          <a:p>
+            <a:pPr>
+              <a:lnSpc>
+                <a:spcPct val="150000"/>
+              </a:lnSpc>
+              <a:buNone/>
+            </a:pPr>
+            <a:r>
+              <a:rPr lang="en-US" altLang="en-US" sz="1300">
+                <a:latin typeface="Arial" panose="020B0604020202020204" pitchFamily="34" charset="0"/>
+              </a:rPr>
+              <a:t>app\Models\Category.php</a:t>
+            </a:r>
+            <a:endParaRPr kumimoji="0" lang="en-US" altLang="en-US" sz="1300" b="0" i="0" u="none" strike="noStrike" cap="none" normalizeH="0" baseline="0">
+              <a:ln>
+                <a:noFill/>
+              </a:ln>
+              <a:solidFill>
+                <a:schemeClr val="tx1"/>
+              </a:solidFill>
+              <a:effectLst/>
+              <a:latin typeface="Arial" panose="020B0604020202020204" pitchFamily="34" charset="0"/>
+            </a:endParaRPr>
+          </a:p>
+        </p:txBody>
+      </p:sp>
+      <p:pic>
+        <p:nvPicPr>
+          <p:cNvPr id="4" name="Picture 3">
+            <a:extLst>
+              <a:ext uri="{FF2B5EF4-FFF2-40B4-BE49-F238E27FC236}">
+                <a16:creationId xmlns:a16="http://schemas.microsoft.com/office/drawing/2014/main" id="{8B78B086-8F67-39EC-FEA9-DCB13F2A47EF}"/>
+              </a:ext>
+            </a:extLst>
+          </p:cNvPr>
+          <p:cNvPicPr>
+            <a:picLocks noChangeAspect="1"/>
+          </p:cNvPicPr>
+          <p:nvPr/>
+        </p:nvPicPr>
+        <p:blipFill>
+          <a:blip r:embed="rId2"/>
+          <a:stretch>
+            <a:fillRect/>
+          </a:stretch>
+        </p:blipFill>
+        <p:spPr>
+          <a:xfrm>
+            <a:off x="7095414" y="0"/>
+            <a:ext cx="5096586" cy="3648584"/>
+          </a:xfrm>
+          <a:prstGeom prst="rect">
+            <a:avLst/>
+          </a:prstGeom>
+        </p:spPr>
+      </p:pic>
+    </p:spTree>
+    <p:extLst>
+      <p:ext uri="{BB962C8B-B14F-4D97-AF65-F5344CB8AC3E}">
+        <p14:creationId xmlns:p14="http://schemas.microsoft.com/office/powerpoint/2010/main" val="2830449130"/>
+      </p:ext>
+    </p:extLst>
+  </p:cSld>
+  <p:clrMapOvr>
+    <a:masterClrMapping/>
+  </p:clrMapOvr>
+</p:sld>
+</file>
+
+<file path=ppt/slides/slide11.xml><?xml version="1.0" encoding="utf-8"?>
+<p:sld xmlns:a="http://schemas.openxmlformats.org/drawingml/2006/main" xmlns:r="http://schemas.openxmlformats.org/officeDocument/2006/relationships" xmlns:p="http://schemas.openxmlformats.org/presentationml/2006/main">
+  <p:cSld>
+    <p:spTree>
+      <p:nvGrpSpPr>
+        <p:cNvPr id="1" name="">
+          <a:extLst>
+            <a:ext uri="{FF2B5EF4-FFF2-40B4-BE49-F238E27FC236}">
+              <a16:creationId xmlns:a16="http://schemas.microsoft.com/office/drawing/2014/main" id="{0A326106-3FF5-BACE-6E48-F0ABC41FDC9C}"/>
+            </a:ext>
+          </a:extLst>
+        </p:cNvPr>
+        <p:cNvGrpSpPr/>
+        <p:nvPr/>
+      </p:nvGrpSpPr>
+      <p:grpSpPr>
+        <a:xfrm>
+          <a:off x="0" y="0"/>
+          <a:ext cx="0" cy="0"/>
+          <a:chOff x="0" y="0"/>
+          <a:chExt cx="0" cy="0"/>
+        </a:xfrm>
+      </p:grpSpPr>
+      <p:sp>
+        <p:nvSpPr>
+          <p:cNvPr id="3" name="TextBox 2">
+            <a:extLst>
+              <a:ext uri="{FF2B5EF4-FFF2-40B4-BE49-F238E27FC236}">
+                <a16:creationId xmlns:a16="http://schemas.microsoft.com/office/drawing/2014/main" id="{05648CBE-D5AC-21C3-0CE5-9532B685B7D0}"/>
+              </a:ext>
+            </a:extLst>
+          </p:cNvPr>
+          <p:cNvSpPr txBox="1"/>
+          <p:nvPr/>
+        </p:nvSpPr>
+        <p:spPr>
+          <a:xfrm>
+            <a:off x="217714" y="255046"/>
+            <a:ext cx="11756571" cy="355354"/>
+          </a:xfrm>
+          <a:prstGeom prst="rect">
+            <a:avLst/>
+          </a:prstGeom>
+          <a:noFill/>
+        </p:spPr>
+        <p:txBody>
+          <a:bodyPr wrap="square">
+            <a:spAutoFit/>
+          </a:bodyPr>
+          <a:lstStyle/>
+          <a:p>
+            <a:pPr>
+              <a:lnSpc>
+                <a:spcPct val="150000"/>
+              </a:lnSpc>
+              <a:buNone/>
+            </a:pPr>
+            <a:r>
+              <a:rPr lang="en-US" altLang="en-US" sz="1300">
+                <a:latin typeface="Arial" panose="020B0604020202020204" pitchFamily="34" charset="0"/>
+              </a:rPr>
+              <a:t>resources\views\frontend\layouts\menu.blade.php</a:t>
+            </a:r>
+            <a:endParaRPr kumimoji="0" lang="en-US" altLang="en-US" sz="1300" b="0" i="0" u="none" strike="noStrike" cap="none" normalizeH="0" baseline="0">
+              <a:ln>
+                <a:noFill/>
+              </a:ln>
+              <a:solidFill>
+                <a:schemeClr val="tx1"/>
+              </a:solidFill>
+              <a:effectLst/>
+              <a:latin typeface="Arial" panose="020B0604020202020204" pitchFamily="34" charset="0"/>
+            </a:endParaRPr>
+          </a:p>
+        </p:txBody>
+      </p:sp>
+      <p:pic>
+        <p:nvPicPr>
+          <p:cNvPr id="4" name="Picture 3">
+            <a:extLst>
+              <a:ext uri="{FF2B5EF4-FFF2-40B4-BE49-F238E27FC236}">
+                <a16:creationId xmlns:a16="http://schemas.microsoft.com/office/drawing/2014/main" id="{94423899-1D58-1C4D-C9F4-D1F913E6C5FA}"/>
+              </a:ext>
+            </a:extLst>
+          </p:cNvPr>
+          <p:cNvPicPr>
+            <a:picLocks noChangeAspect="1"/>
+          </p:cNvPicPr>
+          <p:nvPr/>
+        </p:nvPicPr>
+        <p:blipFill>
+          <a:blip r:embed="rId2"/>
+          <a:stretch>
+            <a:fillRect/>
+          </a:stretch>
+        </p:blipFill>
+        <p:spPr>
+          <a:xfrm>
+            <a:off x="4076580" y="0"/>
+            <a:ext cx="8115420" cy="6858000"/>
+          </a:xfrm>
+          <a:prstGeom prst="rect">
+            <a:avLst/>
+          </a:prstGeom>
+        </p:spPr>
+      </p:pic>
+    </p:spTree>
+    <p:extLst>
+      <p:ext uri="{BB962C8B-B14F-4D97-AF65-F5344CB8AC3E}">
+        <p14:creationId xmlns:p14="http://schemas.microsoft.com/office/powerpoint/2010/main" val="3019654154"/>
+      </p:ext>
+    </p:extLst>
+  </p:cSld>
+  <p:clrMapOvr>
+    <a:masterClrMapping/>
+  </p:clrMapOvr>
+</p:sld>
+</file>
+
+<file path=ppt/slides/slide12.xml><?xml version="1.0" encoding="utf-8"?>
+<p:sld xmlns:a="http://schemas.openxmlformats.org/drawingml/2006/main" xmlns:r="http://schemas.openxmlformats.org/officeDocument/2006/relationships" xmlns:p="http://schemas.openxmlformats.org/presentationml/2006/main">
+  <p:cSld>
+    <p:spTree>
+      <p:nvGrpSpPr>
+        <p:cNvPr id="1" name="">
+          <a:extLst>
+            <a:ext uri="{FF2B5EF4-FFF2-40B4-BE49-F238E27FC236}">
+              <a16:creationId xmlns:a16="http://schemas.microsoft.com/office/drawing/2014/main" id="{98C2A649-00A3-389A-3173-44BCA2A46B81}"/>
+            </a:ext>
+          </a:extLst>
+        </p:cNvPr>
+        <p:cNvGrpSpPr/>
+        <p:nvPr/>
+      </p:nvGrpSpPr>
+      <p:grpSpPr>
+        <a:xfrm>
+          <a:off x="0" y="0"/>
+          <a:ext cx="0" cy="0"/>
+          <a:chOff x="0" y="0"/>
+          <a:chExt cx="0" cy="0"/>
+        </a:xfrm>
+      </p:grpSpPr>
+      <p:sp>
+        <p:nvSpPr>
+          <p:cNvPr id="3" name="TextBox 2">
+            <a:extLst>
+              <a:ext uri="{FF2B5EF4-FFF2-40B4-BE49-F238E27FC236}">
+                <a16:creationId xmlns:a16="http://schemas.microsoft.com/office/drawing/2014/main" id="{5929FC17-B3A0-CA3C-B52A-10FB6034AB51}"/>
+              </a:ext>
+            </a:extLst>
+          </p:cNvPr>
+          <p:cNvSpPr txBox="1"/>
+          <p:nvPr/>
+        </p:nvSpPr>
+        <p:spPr>
+          <a:xfrm>
+            <a:off x="217714" y="255046"/>
+            <a:ext cx="11756571" cy="355354"/>
+          </a:xfrm>
+          <a:prstGeom prst="rect">
+            <a:avLst/>
+          </a:prstGeom>
+          <a:noFill/>
+        </p:spPr>
+        <p:txBody>
+          <a:bodyPr wrap="square">
+            <a:spAutoFit/>
+          </a:bodyPr>
+          <a:lstStyle/>
+          <a:p>
+            <a:pPr>
+              <a:lnSpc>
+                <a:spcPct val="150000"/>
+              </a:lnSpc>
+              <a:buNone/>
+            </a:pPr>
+            <a:r>
+              <a:rPr lang="en-US" altLang="en-US" sz="1300">
+                <a:latin typeface="Arial" panose="020B0604020202020204" pitchFamily="34" charset="0"/>
+              </a:rPr>
+              <a:t>app\Models\SubCategory.php</a:t>
+            </a:r>
+            <a:endParaRPr kumimoji="0" lang="en-US" altLang="en-US" sz="1300" b="0" i="0" u="none" strike="noStrike" cap="none" normalizeH="0" baseline="0">
+              <a:ln>
+                <a:noFill/>
+              </a:ln>
+              <a:solidFill>
+                <a:schemeClr val="tx1"/>
+              </a:solidFill>
+              <a:effectLst/>
+              <a:latin typeface="Arial" panose="020B0604020202020204" pitchFamily="34" charset="0"/>
+            </a:endParaRPr>
+          </a:p>
+        </p:txBody>
+      </p:sp>
+      <p:pic>
+        <p:nvPicPr>
+          <p:cNvPr id="4" name="Picture 3">
+            <a:extLst>
+              <a:ext uri="{FF2B5EF4-FFF2-40B4-BE49-F238E27FC236}">
+                <a16:creationId xmlns:a16="http://schemas.microsoft.com/office/drawing/2014/main" id="{17CFCCD0-0D20-CAD3-A94F-7B46A9583F8D}"/>
+              </a:ext>
+            </a:extLst>
+          </p:cNvPr>
+          <p:cNvPicPr>
+            <a:picLocks noChangeAspect="1"/>
+          </p:cNvPicPr>
+          <p:nvPr/>
+        </p:nvPicPr>
+        <p:blipFill>
+          <a:blip r:embed="rId2"/>
+          <a:stretch>
+            <a:fillRect/>
+          </a:stretch>
+        </p:blipFill>
+        <p:spPr>
+          <a:xfrm>
+            <a:off x="7162098" y="1809045"/>
+            <a:ext cx="5029902" cy="5048955"/>
+          </a:xfrm>
+          <a:prstGeom prst="rect">
+            <a:avLst/>
+          </a:prstGeom>
+        </p:spPr>
+      </p:pic>
+    </p:spTree>
+    <p:extLst>
+      <p:ext uri="{BB962C8B-B14F-4D97-AF65-F5344CB8AC3E}">
+        <p14:creationId xmlns:p14="http://schemas.microsoft.com/office/powerpoint/2010/main" val="3130417956"/>
+      </p:ext>
+    </p:extLst>
+  </p:cSld>
+  <p:clrMapOvr>
+    <a:masterClrMapping/>
+  </p:clrMapOvr>
+</p:sld>
+</file>
+
+<file path=ppt/slides/slide13.xml><?xml version="1.0" encoding="utf-8"?>
+<p:sld xmlns:a="http://schemas.openxmlformats.org/drawingml/2006/main" xmlns:r="http://schemas.openxmlformats.org/officeDocument/2006/relationships" xmlns:p="http://schemas.openxmlformats.org/presentationml/2006/main">
+  <p:cSld>
+    <p:spTree>
+      <p:nvGrpSpPr>
+        <p:cNvPr id="1" name="">
+          <a:extLst>
+            <a:ext uri="{FF2B5EF4-FFF2-40B4-BE49-F238E27FC236}">
+              <a16:creationId xmlns:a16="http://schemas.microsoft.com/office/drawing/2014/main" id="{70AEC777-16C3-416C-C638-BB60E2A3222D}"/>
+            </a:ext>
+          </a:extLst>
+        </p:cNvPr>
+        <p:cNvGrpSpPr/>
+        <p:nvPr/>
+      </p:nvGrpSpPr>
+      <p:grpSpPr>
+        <a:xfrm>
+          <a:off x="0" y="0"/>
+          <a:ext cx="0" cy="0"/>
+          <a:chOff x="0" y="0"/>
+          <a:chExt cx="0" cy="0"/>
+        </a:xfrm>
+      </p:grpSpPr>
+      <p:sp>
+        <p:nvSpPr>
+          <p:cNvPr id="3" name="TextBox 2">
+            <a:extLst>
+              <a:ext uri="{FF2B5EF4-FFF2-40B4-BE49-F238E27FC236}">
+                <a16:creationId xmlns:a16="http://schemas.microsoft.com/office/drawing/2014/main" id="{5F8FDFE4-9C4B-855B-CC91-A762BF7AED32}"/>
+              </a:ext>
+            </a:extLst>
+          </p:cNvPr>
+          <p:cNvSpPr txBox="1"/>
+          <p:nvPr/>
+        </p:nvSpPr>
+        <p:spPr>
+          <a:xfrm>
+            <a:off x="217714" y="255046"/>
+            <a:ext cx="11756571" cy="355354"/>
+          </a:xfrm>
+          <a:prstGeom prst="rect">
+            <a:avLst/>
+          </a:prstGeom>
+          <a:noFill/>
+        </p:spPr>
+        <p:txBody>
+          <a:bodyPr wrap="square">
+            <a:spAutoFit/>
+          </a:bodyPr>
+          <a:lstStyle/>
+          <a:p>
+            <a:pPr>
+              <a:lnSpc>
+                <a:spcPct val="150000"/>
+              </a:lnSpc>
+              <a:buNone/>
+            </a:pPr>
+            <a:r>
+              <a:rPr lang="en-US" altLang="en-US" sz="1300">
+                <a:latin typeface="Arial" panose="020B0604020202020204" pitchFamily="34" charset="0"/>
+              </a:rPr>
+              <a:t>resources\views\frontend\layouts\menu.blade.php</a:t>
+            </a:r>
+            <a:endParaRPr kumimoji="0" lang="en-US" altLang="en-US" sz="1300" b="0" i="0" u="none" strike="noStrike" cap="none" normalizeH="0" baseline="0">
+              <a:ln>
+                <a:noFill/>
+              </a:ln>
+              <a:solidFill>
+                <a:schemeClr val="tx1"/>
+              </a:solidFill>
+              <a:effectLst/>
+              <a:latin typeface="Arial" panose="020B0604020202020204" pitchFamily="34" charset="0"/>
+            </a:endParaRPr>
+          </a:p>
+        </p:txBody>
+      </p:sp>
+      <p:pic>
+        <p:nvPicPr>
+          <p:cNvPr id="4" name="Picture 3">
+            <a:extLst>
+              <a:ext uri="{FF2B5EF4-FFF2-40B4-BE49-F238E27FC236}">
+                <a16:creationId xmlns:a16="http://schemas.microsoft.com/office/drawing/2014/main" id="{E6364B7F-AB1E-26D7-0E64-BD23A73434E4}"/>
+              </a:ext>
+            </a:extLst>
+          </p:cNvPr>
+          <p:cNvPicPr>
+            <a:picLocks noChangeAspect="1"/>
+          </p:cNvPicPr>
+          <p:nvPr/>
+        </p:nvPicPr>
+        <p:blipFill>
+          <a:blip r:embed="rId2"/>
+          <a:stretch>
+            <a:fillRect/>
+          </a:stretch>
+        </p:blipFill>
+        <p:spPr>
+          <a:xfrm>
+            <a:off x="4088967" y="0"/>
+            <a:ext cx="8103033" cy="6858000"/>
+          </a:xfrm>
+          <a:prstGeom prst="rect">
+            <a:avLst/>
+          </a:prstGeom>
+        </p:spPr>
+      </p:pic>
+    </p:spTree>
+    <p:extLst>
+      <p:ext uri="{BB962C8B-B14F-4D97-AF65-F5344CB8AC3E}">
+        <p14:creationId xmlns:p14="http://schemas.microsoft.com/office/powerpoint/2010/main" val="488172730"/>
+      </p:ext>
+    </p:extLst>
+  </p:cSld>
+  <p:clrMapOvr>
+    <a:masterClrMapping/>
+  </p:clrMapOvr>
+</p:sld>
+</file>
+
+<file path=ppt/slides/slide14.xml><?xml version="1.0" encoding="utf-8"?>
+<p:sld xmlns:a="http://schemas.openxmlformats.org/drawingml/2006/main" xmlns:r="http://schemas.openxmlformats.org/officeDocument/2006/relationships" xmlns:p="http://schemas.openxmlformats.org/presentationml/2006/main">
+  <p:cSld>
+    <p:spTree>
+      <p:nvGrpSpPr>
+        <p:cNvPr id="1" name="">
+          <a:extLst>
+            <a:ext uri="{FF2B5EF4-FFF2-40B4-BE49-F238E27FC236}">
+              <a16:creationId xmlns:a16="http://schemas.microsoft.com/office/drawing/2014/main" id="{7075BB28-33B7-636F-CE3D-ABED2DC085F2}"/>
+            </a:ext>
+          </a:extLst>
+        </p:cNvPr>
+        <p:cNvGrpSpPr/>
+        <p:nvPr/>
+      </p:nvGrpSpPr>
+      <p:grpSpPr>
+        <a:xfrm>
+          <a:off x="0" y="0"/>
+          <a:ext cx="0" cy="0"/>
+          <a:chOff x="0" y="0"/>
+          <a:chExt cx="0" cy="0"/>
+        </a:xfrm>
+      </p:grpSpPr>
+      <p:sp>
+        <p:nvSpPr>
+          <p:cNvPr id="3" name="TextBox 2">
+            <a:extLst>
+              <a:ext uri="{FF2B5EF4-FFF2-40B4-BE49-F238E27FC236}">
+                <a16:creationId xmlns:a16="http://schemas.microsoft.com/office/drawing/2014/main" id="{930826BE-3046-C697-BE3C-C2EF52AD0079}"/>
+              </a:ext>
+            </a:extLst>
+          </p:cNvPr>
+          <p:cNvSpPr txBox="1"/>
+          <p:nvPr/>
+        </p:nvSpPr>
+        <p:spPr>
+          <a:xfrm>
+            <a:off x="217714" y="255046"/>
+            <a:ext cx="11756571" cy="355354"/>
+          </a:xfrm>
+          <a:prstGeom prst="rect">
+            <a:avLst/>
+          </a:prstGeom>
+          <a:noFill/>
+        </p:spPr>
+        <p:txBody>
+          <a:bodyPr wrap="square">
+            <a:spAutoFit/>
+          </a:bodyPr>
+          <a:lstStyle/>
+          <a:p>
+            <a:pPr>
+              <a:lnSpc>
+                <a:spcPct val="150000"/>
+              </a:lnSpc>
+              <a:buNone/>
+            </a:pPr>
+            <a:r>
+              <a:rPr lang="en-US" altLang="en-US" sz="1300">
+                <a:latin typeface="Arial" panose="020B0604020202020204" pitchFamily="34" charset="0"/>
+              </a:rPr>
+              <a:t>resources\views\frontend\layouts\menu.blade.php</a:t>
+            </a:r>
+          </a:p>
+        </p:txBody>
+      </p:sp>
+      <p:pic>
+        <p:nvPicPr>
+          <p:cNvPr id="4" name="Picture 3">
+            <a:extLst>
+              <a:ext uri="{FF2B5EF4-FFF2-40B4-BE49-F238E27FC236}">
+                <a16:creationId xmlns:a16="http://schemas.microsoft.com/office/drawing/2014/main" id="{0C8966BA-B006-D8D4-AAAA-BA7F3E9B172E}"/>
+              </a:ext>
+            </a:extLst>
+          </p:cNvPr>
+          <p:cNvPicPr>
+            <a:picLocks noChangeAspect="1"/>
+          </p:cNvPicPr>
+          <p:nvPr/>
+        </p:nvPicPr>
+        <p:blipFill>
+          <a:blip r:embed="rId2"/>
+          <a:stretch>
+            <a:fillRect/>
+          </a:stretch>
+        </p:blipFill>
+        <p:spPr>
+          <a:xfrm>
+            <a:off x="4379784" y="0"/>
+            <a:ext cx="7812216" cy="6858000"/>
+          </a:xfrm>
+          <a:prstGeom prst="rect">
+            <a:avLst/>
+          </a:prstGeom>
+        </p:spPr>
+      </p:pic>
+    </p:spTree>
+    <p:extLst>
+      <p:ext uri="{BB962C8B-B14F-4D97-AF65-F5344CB8AC3E}">
+        <p14:creationId xmlns:p14="http://schemas.microsoft.com/office/powerpoint/2010/main" val="2845993599"/>
+      </p:ext>
+    </p:extLst>
+  </p:cSld>
+  <p:clrMapOvr>
+    <a:masterClrMapping/>
+  </p:clrMapOvr>
+</p:sld>
+</file>
+
+<file path=ppt/slides/slide15.xml><?xml version="1.0" encoding="utf-8"?>
+<p:sld xmlns:a="http://schemas.openxmlformats.org/drawingml/2006/main" xmlns:r="http://schemas.openxmlformats.org/officeDocument/2006/relationships" xmlns:p="http://schemas.openxmlformats.org/presentationml/2006/main">
+  <p:cSld>
+    <p:spTree>
+      <p:nvGrpSpPr>
+        <p:cNvPr id="1" name="">
+          <a:extLst>
+            <a:ext uri="{FF2B5EF4-FFF2-40B4-BE49-F238E27FC236}">
+              <a16:creationId xmlns:a16="http://schemas.microsoft.com/office/drawing/2014/main" id="{6E518BA4-8CB3-7760-9C2C-AF03F3C00573}"/>
+            </a:ext>
+          </a:extLst>
+        </p:cNvPr>
+        <p:cNvGrpSpPr/>
+        <p:nvPr/>
+      </p:nvGrpSpPr>
+      <p:grpSpPr>
+        <a:xfrm>
+          <a:off x="0" y="0"/>
+          <a:ext cx="0" cy="0"/>
+          <a:chOff x="0" y="0"/>
+          <a:chExt cx="0" cy="0"/>
+        </a:xfrm>
+      </p:grpSpPr>
+      <p:sp>
+        <p:nvSpPr>
+          <p:cNvPr id="3" name="TextBox 2">
+            <a:extLst>
+              <a:ext uri="{FF2B5EF4-FFF2-40B4-BE49-F238E27FC236}">
+                <a16:creationId xmlns:a16="http://schemas.microsoft.com/office/drawing/2014/main" id="{E04C43DC-F0E9-BC19-92DA-C2630481D753}"/>
+              </a:ext>
+            </a:extLst>
+          </p:cNvPr>
+          <p:cNvSpPr txBox="1"/>
+          <p:nvPr/>
+        </p:nvSpPr>
+        <p:spPr>
+          <a:xfrm>
+            <a:off x="217714" y="190391"/>
+            <a:ext cx="11756571" cy="355354"/>
+          </a:xfrm>
+          <a:prstGeom prst="rect">
+            <a:avLst/>
+          </a:prstGeom>
+          <a:noFill/>
+        </p:spPr>
+        <p:txBody>
+          <a:bodyPr wrap="square">
+            <a:spAutoFit/>
+          </a:bodyPr>
+          <a:lstStyle/>
+          <a:p>
+            <a:pPr>
+              <a:lnSpc>
+                <a:spcPct val="150000"/>
+              </a:lnSpc>
+              <a:buNone/>
+            </a:pPr>
+            <a:r>
+              <a:rPr lang="en-US" altLang="en-US" sz="1300">
+                <a:latin typeface="Arial" panose="020B0604020202020204" pitchFamily="34" charset="0"/>
+              </a:rPr>
+              <a:t>resources\views\frontend\layouts\menu.blade.php</a:t>
+            </a:r>
+            <a:endParaRPr kumimoji="0" lang="en-US" altLang="en-US" sz="1300" b="0" i="0" u="none" strike="noStrike" cap="none" normalizeH="0" baseline="0">
+              <a:ln>
+                <a:noFill/>
+              </a:ln>
+              <a:solidFill>
+                <a:schemeClr val="tx1"/>
+              </a:solidFill>
+              <a:effectLst/>
+              <a:latin typeface="Arial" panose="020B0604020202020204" pitchFamily="34" charset="0"/>
+            </a:endParaRPr>
+          </a:p>
+        </p:txBody>
+      </p:sp>
+      <p:pic>
+        <p:nvPicPr>
+          <p:cNvPr id="4" name="Picture 3">
+            <a:extLst>
+              <a:ext uri="{FF2B5EF4-FFF2-40B4-BE49-F238E27FC236}">
+                <a16:creationId xmlns:a16="http://schemas.microsoft.com/office/drawing/2014/main" id="{D9A89119-70AA-48FC-8B8B-82A2D8900845}"/>
+              </a:ext>
+            </a:extLst>
+          </p:cNvPr>
+          <p:cNvPicPr>
+            <a:picLocks noChangeAspect="1"/>
+          </p:cNvPicPr>
+          <p:nvPr/>
+        </p:nvPicPr>
+        <p:blipFill>
+          <a:blip r:embed="rId2"/>
+          <a:stretch>
+            <a:fillRect/>
+          </a:stretch>
+        </p:blipFill>
+        <p:spPr>
+          <a:xfrm>
+            <a:off x="2540000" y="720854"/>
+            <a:ext cx="9652000" cy="6137145"/>
+          </a:xfrm>
+          <a:prstGeom prst="rect">
+            <a:avLst/>
+          </a:prstGeom>
+        </p:spPr>
+      </p:pic>
+    </p:spTree>
+    <p:extLst>
+      <p:ext uri="{BB962C8B-B14F-4D97-AF65-F5344CB8AC3E}">
+        <p14:creationId xmlns:p14="http://schemas.microsoft.com/office/powerpoint/2010/main" val="631570898"/>
+      </p:ext>
+    </p:extLst>
+  </p:cSld>
+  <p:clrMapOvr>
+    <a:masterClrMapping/>
+  </p:clrMapOvr>
+</p:sld>
+</file>
+
+<file path=ppt/slides/slide16.xml><?xml version="1.0" encoding="utf-8"?>
+<p:sld xmlns:a="http://schemas.openxmlformats.org/drawingml/2006/main" xmlns:r="http://schemas.openxmlformats.org/officeDocument/2006/relationships" xmlns:p="http://schemas.openxmlformats.org/presentationml/2006/main">
+  <p:cSld>
+    <p:spTree>
+      <p:nvGrpSpPr>
+        <p:cNvPr id="1" name="">
+          <a:extLst>
+            <a:ext uri="{FF2B5EF4-FFF2-40B4-BE49-F238E27FC236}">
+              <a16:creationId xmlns:a16="http://schemas.microsoft.com/office/drawing/2014/main" id="{06890F25-48C2-319F-7A80-845D658BD73D}"/>
+            </a:ext>
+          </a:extLst>
+        </p:cNvPr>
+        <p:cNvGrpSpPr/>
+        <p:nvPr/>
+      </p:nvGrpSpPr>
+      <p:grpSpPr>
+        <a:xfrm>
+          <a:off x="0" y="0"/>
+          <a:ext cx="0" cy="0"/>
+          <a:chOff x="0" y="0"/>
+          <a:chExt cx="0" cy="0"/>
+        </a:xfrm>
+      </p:grpSpPr>
+      <p:sp>
+        <p:nvSpPr>
+          <p:cNvPr id="3" name="TextBox 2">
+            <a:extLst>
+              <a:ext uri="{FF2B5EF4-FFF2-40B4-BE49-F238E27FC236}">
+                <a16:creationId xmlns:a16="http://schemas.microsoft.com/office/drawing/2014/main" id="{B3E1B389-CA51-5299-466E-9816599E4CDD}"/>
+              </a:ext>
+            </a:extLst>
+          </p:cNvPr>
+          <p:cNvSpPr txBox="1"/>
+          <p:nvPr/>
+        </p:nvSpPr>
+        <p:spPr>
+          <a:xfrm>
+            <a:off x="217714" y="255046"/>
+            <a:ext cx="11756571" cy="355354"/>
+          </a:xfrm>
+          <a:prstGeom prst="rect">
+            <a:avLst/>
+          </a:prstGeom>
+          <a:noFill/>
+        </p:spPr>
+        <p:txBody>
+          <a:bodyPr wrap="square">
+            <a:spAutoFit/>
+          </a:bodyPr>
+          <a:lstStyle/>
+          <a:p>
+            <a:pPr>
+              <a:lnSpc>
+                <a:spcPct val="150000"/>
+              </a:lnSpc>
+              <a:buNone/>
+            </a:pPr>
+            <a:r>
+              <a:rPr kumimoji="0" lang="en-US" altLang="en-US" sz="1300" b="0" i="0" u="none" strike="noStrike" cap="none" normalizeH="0" baseline="0">
+                <a:ln>
+                  <a:noFill/>
+                </a:ln>
+                <a:solidFill>
+                  <a:schemeClr val="tx1"/>
+                </a:solidFill>
+                <a:effectLst/>
+                <a:latin typeface="Arial" panose="020B0604020202020204" pitchFamily="34" charset="0"/>
+              </a:rPr>
+              <a:t>.</a:t>
+            </a:r>
+          </a:p>
+        </p:txBody>
+      </p:sp>
+    </p:spTree>
+    <p:extLst>
+      <p:ext uri="{BB962C8B-B14F-4D97-AF65-F5344CB8AC3E}">
+        <p14:creationId xmlns:p14="http://schemas.microsoft.com/office/powerpoint/2010/main" val="3797350010"/>
+      </p:ext>
+    </p:extLst>
+  </p:cSld>
+  <p:clrMapOvr>
+    <a:masterClrMapping/>
+  </p:clrMapOvr>
+</p:sld>
+</file>
+
+<file path=ppt/slides/slide17.xml><?xml version="1.0" encoding="utf-8"?>
+<p:sld xmlns:a="http://schemas.openxmlformats.org/drawingml/2006/main" xmlns:r="http://schemas.openxmlformats.org/officeDocument/2006/relationships" xmlns:p="http://schemas.openxmlformats.org/presentationml/2006/main">
+  <p:cSld>
+    <p:spTree>
+      <p:nvGrpSpPr>
+        <p:cNvPr id="1" name="">
+          <a:extLst>
+            <a:ext uri="{FF2B5EF4-FFF2-40B4-BE49-F238E27FC236}">
+              <a16:creationId xmlns:a16="http://schemas.microsoft.com/office/drawing/2014/main" id="{2D4BD9F2-5186-EC7C-F783-2E4C3BBF2DC2}"/>
+            </a:ext>
+          </a:extLst>
+        </p:cNvPr>
+        <p:cNvGrpSpPr/>
+        <p:nvPr/>
+      </p:nvGrpSpPr>
+      <p:grpSpPr>
+        <a:xfrm>
+          <a:off x="0" y="0"/>
+          <a:ext cx="0" cy="0"/>
+          <a:chOff x="0" y="0"/>
+          <a:chExt cx="0" cy="0"/>
+        </a:xfrm>
+      </p:grpSpPr>
+      <p:sp>
+        <p:nvSpPr>
+          <p:cNvPr id="3" name="TextBox 2">
+            <a:extLst>
+              <a:ext uri="{FF2B5EF4-FFF2-40B4-BE49-F238E27FC236}">
+                <a16:creationId xmlns:a16="http://schemas.microsoft.com/office/drawing/2014/main" id="{5B651225-86D4-F19C-AFA4-C4557CD82E70}"/>
+              </a:ext>
+            </a:extLst>
+          </p:cNvPr>
+          <p:cNvSpPr txBox="1"/>
+          <p:nvPr/>
+        </p:nvSpPr>
+        <p:spPr>
+          <a:xfrm>
+            <a:off x="217714" y="255046"/>
+            <a:ext cx="11756571" cy="355354"/>
+          </a:xfrm>
+          <a:prstGeom prst="rect">
+            <a:avLst/>
+          </a:prstGeom>
+          <a:noFill/>
+        </p:spPr>
+        <p:txBody>
+          <a:bodyPr wrap="square">
+            <a:spAutoFit/>
+          </a:bodyPr>
+          <a:lstStyle/>
+          <a:p>
+            <a:pPr>
+              <a:lnSpc>
+                <a:spcPct val="150000"/>
+              </a:lnSpc>
+              <a:buNone/>
+            </a:pPr>
+            <a:r>
+              <a:rPr kumimoji="0" lang="en-US" altLang="en-US" sz="1300" b="0" i="0" u="none" strike="noStrike" cap="none" normalizeH="0" baseline="0">
+                <a:ln>
+                  <a:noFill/>
+                </a:ln>
+                <a:solidFill>
+                  <a:schemeClr val="tx1"/>
+                </a:solidFill>
+                <a:effectLst/>
+                <a:latin typeface="Arial" panose="020B0604020202020204" pitchFamily="34" charset="0"/>
+              </a:rPr>
+              <a:t>.</a:t>
+            </a:r>
+          </a:p>
+        </p:txBody>
+      </p:sp>
+    </p:spTree>
+    <p:extLst>
+      <p:ext uri="{BB962C8B-B14F-4D97-AF65-F5344CB8AC3E}">
+        <p14:creationId xmlns:p14="http://schemas.microsoft.com/office/powerpoint/2010/main" val="2513515664"/>
       </p:ext>
     </p:extLst>
   </p:cSld>
@@ -3470,6 +4404,50 @@
           </a:p>
         </p:txBody>
       </p:sp>
+      <p:pic>
+        <p:nvPicPr>
+          <p:cNvPr id="4" name="Picture 3">
+            <a:extLst>
+              <a:ext uri="{FF2B5EF4-FFF2-40B4-BE49-F238E27FC236}">
+                <a16:creationId xmlns:a16="http://schemas.microsoft.com/office/drawing/2014/main" id="{87A7BCDB-0E45-F34C-90DB-C2BFBD9E96AB}"/>
+              </a:ext>
+            </a:extLst>
+          </p:cNvPr>
+          <p:cNvPicPr>
+            <a:picLocks noChangeAspect="1"/>
+          </p:cNvPicPr>
+          <p:nvPr/>
+        </p:nvPicPr>
+        <p:blipFill>
+          <a:blip r:embed="rId2"/>
+          <a:stretch>
+            <a:fillRect/>
+          </a:stretch>
+        </p:blipFill>
+        <p:spPr>
+          <a:xfrm>
+            <a:off x="-1" y="1109589"/>
+            <a:ext cx="12192000" cy="5266893"/>
+          </a:xfrm>
+          <a:prstGeom prst="rect">
+            <a:avLst/>
+          </a:prstGeom>
+          <a:ln w="38100" cap="sq">
+            <a:solidFill>
+              <a:srgbClr val="000000"/>
+            </a:solidFill>
+            <a:prstDash val="solid"/>
+            <a:miter lim="800000"/>
+          </a:ln>
+          <a:effectLst>
+            <a:outerShdw blurRad="50800" dist="38100" dir="2700000" algn="tl" rotWithShape="0">
+              <a:srgbClr val="000000">
+                <a:alpha val="43000"/>
+              </a:srgbClr>
+            </a:outerShdw>
+          </a:effectLst>
+        </p:spPr>
+      </p:pic>
     </p:spTree>
     <p:extLst>
       <p:ext uri="{BB962C8B-B14F-4D97-AF65-F5344CB8AC3E}">
@@ -3484,6 +4462,1423 @@
 </file>
 
 <file path=ppt/slides/slide3.xml><?xml version="1.0" encoding="utf-8"?>
+<p:sld xmlns:a="http://schemas.openxmlformats.org/drawingml/2006/main" xmlns:r="http://schemas.openxmlformats.org/officeDocument/2006/relationships" xmlns:p="http://schemas.openxmlformats.org/presentationml/2006/main">
+  <p:cSld>
+    <p:spTree>
+      <p:nvGrpSpPr>
+        <p:cNvPr id="1" name="">
+          <a:extLst>
+            <a:ext uri="{FF2B5EF4-FFF2-40B4-BE49-F238E27FC236}">
+              <a16:creationId xmlns:a16="http://schemas.microsoft.com/office/drawing/2014/main" id="{D169BD25-D151-EF28-7470-186464CD296D}"/>
+            </a:ext>
+          </a:extLst>
+        </p:cNvPr>
+        <p:cNvGrpSpPr/>
+        <p:nvPr/>
+      </p:nvGrpSpPr>
+      <p:grpSpPr>
+        <a:xfrm>
+          <a:off x="0" y="0"/>
+          <a:ext cx="0" cy="0"/>
+          <a:chOff x="0" y="0"/>
+          <a:chExt cx="0" cy="0"/>
+        </a:xfrm>
+      </p:grpSpPr>
+      <p:sp>
+        <p:nvSpPr>
+          <p:cNvPr id="3" name="TextBox 2">
+            <a:extLst>
+              <a:ext uri="{FF2B5EF4-FFF2-40B4-BE49-F238E27FC236}">
+                <a16:creationId xmlns:a16="http://schemas.microsoft.com/office/drawing/2014/main" id="{B0978EDF-253F-604E-1825-7947A35E4DCB}"/>
+              </a:ext>
+            </a:extLst>
+          </p:cNvPr>
+          <p:cNvSpPr txBox="1"/>
+          <p:nvPr/>
+        </p:nvSpPr>
+        <p:spPr>
+          <a:xfrm>
+            <a:off x="217714" y="255046"/>
+            <a:ext cx="11756571" cy="355354"/>
+          </a:xfrm>
+          <a:prstGeom prst="rect">
+            <a:avLst/>
+          </a:prstGeom>
+          <a:noFill/>
+        </p:spPr>
+        <p:txBody>
+          <a:bodyPr wrap="square">
+            <a:spAutoFit/>
+          </a:bodyPr>
+          <a:lstStyle/>
+          <a:p>
+            <a:pPr>
+              <a:lnSpc>
+                <a:spcPct val="150000"/>
+              </a:lnSpc>
+              <a:buNone/>
+            </a:pPr>
+            <a:r>
+              <a:rPr kumimoji="0" lang="en-US" altLang="en-US" sz="1300" b="0" i="0" u="none" strike="noStrike" cap="none" normalizeH="0" baseline="0">
+                <a:ln>
+                  <a:noFill/>
+                </a:ln>
+                <a:solidFill>
+                  <a:schemeClr val="tx1"/>
+                </a:solidFill>
+                <a:effectLst/>
+                <a:latin typeface="Arial" panose="020B0604020202020204" pitchFamily="34" charset="0"/>
+              </a:rPr>
+              <a:t>.</a:t>
+            </a:r>
+          </a:p>
+        </p:txBody>
+      </p:sp>
+      <p:pic>
+        <p:nvPicPr>
+          <p:cNvPr id="4" name="Picture 3">
+            <a:extLst>
+              <a:ext uri="{FF2B5EF4-FFF2-40B4-BE49-F238E27FC236}">
+                <a16:creationId xmlns:a16="http://schemas.microsoft.com/office/drawing/2014/main" id="{B6D0729B-39FE-AA28-7D88-54C64E9C51F9}"/>
+              </a:ext>
+            </a:extLst>
+          </p:cNvPr>
+          <p:cNvPicPr>
+            <a:picLocks noChangeAspect="1"/>
+          </p:cNvPicPr>
+          <p:nvPr/>
+        </p:nvPicPr>
+        <p:blipFill>
+          <a:blip r:embed="rId2"/>
+          <a:stretch>
+            <a:fillRect/>
+          </a:stretch>
+        </p:blipFill>
+        <p:spPr>
+          <a:xfrm>
+            <a:off x="0" y="1284582"/>
+            <a:ext cx="12192000" cy="4288835"/>
+          </a:xfrm>
+          <a:prstGeom prst="rect">
+            <a:avLst/>
+          </a:prstGeom>
+          <a:ln w="38100" cap="sq">
+            <a:solidFill>
+              <a:srgbClr val="000000"/>
+            </a:solidFill>
+            <a:prstDash val="solid"/>
+            <a:miter lim="800000"/>
+          </a:ln>
+          <a:effectLst>
+            <a:outerShdw blurRad="50800" dist="38100" dir="2700000" algn="tl" rotWithShape="0">
+              <a:srgbClr val="000000">
+                <a:alpha val="43000"/>
+              </a:srgbClr>
+            </a:outerShdw>
+          </a:effectLst>
+        </p:spPr>
+      </p:pic>
+    </p:spTree>
+    <p:extLst>
+      <p:ext uri="{BB962C8B-B14F-4D97-AF65-F5344CB8AC3E}">
+        <p14:creationId xmlns:p14="http://schemas.microsoft.com/office/powerpoint/2010/main" val="358077850"/>
+      </p:ext>
+    </p:extLst>
+  </p:cSld>
+  <p:clrMapOvr>
+    <a:masterClrMapping/>
+  </p:clrMapOvr>
+</p:sld>
+</file>
+
+<file path=ppt/slides/slide4.xml><?xml version="1.0" encoding="utf-8"?>
+<p:sld xmlns:a="http://schemas.openxmlformats.org/drawingml/2006/main" xmlns:r="http://schemas.openxmlformats.org/officeDocument/2006/relationships" xmlns:p="http://schemas.openxmlformats.org/presentationml/2006/main">
+  <p:cSld>
+    <p:spTree>
+      <p:nvGrpSpPr>
+        <p:cNvPr id="1" name="">
+          <a:extLst>
+            <a:ext uri="{FF2B5EF4-FFF2-40B4-BE49-F238E27FC236}">
+              <a16:creationId xmlns:a16="http://schemas.microsoft.com/office/drawing/2014/main" id="{DA1655D2-25C3-354C-17D0-67F2840F8F16}"/>
+            </a:ext>
+          </a:extLst>
+        </p:cNvPr>
+        <p:cNvGrpSpPr/>
+        <p:nvPr/>
+      </p:nvGrpSpPr>
+      <p:grpSpPr>
+        <a:xfrm>
+          <a:off x="0" y="0"/>
+          <a:ext cx="0" cy="0"/>
+          <a:chOff x="0" y="0"/>
+          <a:chExt cx="0" cy="0"/>
+        </a:xfrm>
+      </p:grpSpPr>
+      <p:sp>
+        <p:nvSpPr>
+          <p:cNvPr id="3" name="TextBox 2">
+            <a:extLst>
+              <a:ext uri="{FF2B5EF4-FFF2-40B4-BE49-F238E27FC236}">
+                <a16:creationId xmlns:a16="http://schemas.microsoft.com/office/drawing/2014/main" id="{397E11E0-4758-3615-5149-21DA5FE472E7}"/>
+              </a:ext>
+            </a:extLst>
+          </p:cNvPr>
+          <p:cNvSpPr txBox="1"/>
+          <p:nvPr/>
+        </p:nvSpPr>
+        <p:spPr>
+          <a:xfrm>
+            <a:off x="217714" y="255046"/>
+            <a:ext cx="11756571" cy="355354"/>
+          </a:xfrm>
+          <a:prstGeom prst="rect">
+            <a:avLst/>
+          </a:prstGeom>
+          <a:noFill/>
+        </p:spPr>
+        <p:txBody>
+          <a:bodyPr wrap="square">
+            <a:spAutoFit/>
+          </a:bodyPr>
+          <a:lstStyle/>
+          <a:p>
+            <a:pPr>
+              <a:lnSpc>
+                <a:spcPct val="150000"/>
+              </a:lnSpc>
+              <a:buNone/>
+            </a:pPr>
+            <a:r>
+              <a:rPr lang="en-US" altLang="en-US" sz="1300">
+                <a:latin typeface="Arial" panose="020B0604020202020204" pitchFamily="34" charset="0"/>
+              </a:rPr>
+              <a:t>resources\views\frontend\layouts\menu.blade.php</a:t>
+            </a:r>
+            <a:endParaRPr kumimoji="0" lang="en-US" altLang="en-US" sz="1300" b="0" i="0" u="none" strike="noStrike" cap="none" normalizeH="0" baseline="0">
+              <a:ln>
+                <a:noFill/>
+              </a:ln>
+              <a:solidFill>
+                <a:schemeClr val="tx1"/>
+              </a:solidFill>
+              <a:effectLst/>
+              <a:latin typeface="Arial" panose="020B0604020202020204" pitchFamily="34" charset="0"/>
+            </a:endParaRPr>
+          </a:p>
+        </p:txBody>
+      </p:sp>
+      <p:pic>
+        <p:nvPicPr>
+          <p:cNvPr id="4" name="Picture 3">
+            <a:extLst>
+              <a:ext uri="{FF2B5EF4-FFF2-40B4-BE49-F238E27FC236}">
+                <a16:creationId xmlns:a16="http://schemas.microsoft.com/office/drawing/2014/main" id="{3C62301B-6504-C0C9-4E7D-BF6FF1AC66DE}"/>
+              </a:ext>
+            </a:extLst>
+          </p:cNvPr>
+          <p:cNvPicPr>
+            <a:picLocks noChangeAspect="1"/>
+          </p:cNvPicPr>
+          <p:nvPr/>
+        </p:nvPicPr>
+        <p:blipFill>
+          <a:blip r:embed="rId2"/>
+          <a:stretch>
+            <a:fillRect/>
+          </a:stretch>
+        </p:blipFill>
+        <p:spPr>
+          <a:xfrm>
+            <a:off x="4166770" y="877454"/>
+            <a:ext cx="8025229" cy="5980545"/>
+          </a:xfrm>
+          <a:prstGeom prst="rect">
+            <a:avLst/>
+          </a:prstGeom>
+        </p:spPr>
+      </p:pic>
+    </p:spTree>
+    <p:extLst>
+      <p:ext uri="{BB962C8B-B14F-4D97-AF65-F5344CB8AC3E}">
+        <p14:creationId xmlns:p14="http://schemas.microsoft.com/office/powerpoint/2010/main" val="3179676302"/>
+      </p:ext>
+    </p:extLst>
+  </p:cSld>
+  <p:clrMapOvr>
+    <a:masterClrMapping/>
+  </p:clrMapOvr>
+</p:sld>
+</file>
+
+<file path=ppt/slides/slide5.xml><?xml version="1.0" encoding="utf-8"?>
+<p:sld xmlns:a="http://schemas.openxmlformats.org/drawingml/2006/main" xmlns:r="http://schemas.openxmlformats.org/officeDocument/2006/relationships" xmlns:p="http://schemas.openxmlformats.org/presentationml/2006/main">
+  <p:cSld>
+    <p:spTree>
+      <p:nvGrpSpPr>
+        <p:cNvPr id="1" name="">
+          <a:extLst>
+            <a:ext uri="{FF2B5EF4-FFF2-40B4-BE49-F238E27FC236}">
+              <a16:creationId xmlns:a16="http://schemas.microsoft.com/office/drawing/2014/main" id="{677DCAC6-16FA-330D-FA17-5F3E24121CA4}"/>
+            </a:ext>
+          </a:extLst>
+        </p:cNvPr>
+        <p:cNvGrpSpPr/>
+        <p:nvPr/>
+      </p:nvGrpSpPr>
+      <p:grpSpPr>
+        <a:xfrm>
+          <a:off x="0" y="0"/>
+          <a:ext cx="0" cy="0"/>
+          <a:chOff x="0" y="0"/>
+          <a:chExt cx="0" cy="0"/>
+        </a:xfrm>
+      </p:grpSpPr>
+      <p:sp>
+        <p:nvSpPr>
+          <p:cNvPr id="3" name="TextBox 2">
+            <a:extLst>
+              <a:ext uri="{FF2B5EF4-FFF2-40B4-BE49-F238E27FC236}">
+                <a16:creationId xmlns:a16="http://schemas.microsoft.com/office/drawing/2014/main" id="{DAADB6FA-B43B-E2F4-7C7E-35B91182C72C}"/>
+              </a:ext>
+            </a:extLst>
+          </p:cNvPr>
+          <p:cNvSpPr txBox="1"/>
+          <p:nvPr/>
+        </p:nvSpPr>
+        <p:spPr>
+          <a:xfrm>
+            <a:off x="217714" y="255046"/>
+            <a:ext cx="11756571" cy="4856586"/>
+          </a:xfrm>
+          <a:prstGeom prst="rect">
+            <a:avLst/>
+          </a:prstGeom>
+          <a:noFill/>
+        </p:spPr>
+        <p:txBody>
+          <a:bodyPr wrap="square">
+            <a:spAutoFit/>
+          </a:bodyPr>
+          <a:lstStyle/>
+          <a:p>
+            <a:pPr>
+              <a:lnSpc>
+                <a:spcPct val="150000"/>
+              </a:lnSpc>
+              <a:buNone/>
+            </a:pPr>
+            <a:r>
+              <a:rPr lang="az-Latn-AZ" altLang="en-US" sz="1300">
+                <a:latin typeface="Arial" panose="020B0604020202020204" pitchFamily="34" charset="0"/>
+              </a:rPr>
+              <a:t>Controllerdən də, bütün Categor -ləri göndərə bilərdik. Əslində bizim yazdığımız </a:t>
+            </a:r>
+            <a:r>
+              <a:rPr lang="az-Latn-AZ" altLang="en-US" sz="1300" b="1">
+                <a:solidFill>
+                  <a:srgbClr val="FF0000"/>
+                </a:solidFill>
+                <a:latin typeface="Arial" panose="020B0604020202020204" pitchFamily="34" charset="0"/>
+              </a:rPr>
+              <a:t>@php $categories = \App\Models\Category::all(); @endphp </a:t>
+            </a:r>
+            <a:r>
+              <a:rPr lang="az-Latn-AZ" altLang="en-US" sz="1300">
+                <a:latin typeface="Arial" panose="020B0604020202020204" pitchFamily="34" charset="0"/>
+              </a:rPr>
+              <a:t>kodu işləyir, amma professional yanaşma sayılmır. Blade faylında birbaşa model çağırmaq MVC (Model–View–Controller) prinsipini pozur. Yəni View (blade) içində Model-dən məlumat çəkmək əvəzinə, məlumatı Controller və ya View Composer ilə göndərmək daha düzgündür.</a:t>
+            </a:r>
+            <a:endParaRPr lang="en-US" altLang="en-US" sz="1300">
+              <a:latin typeface="Arial" panose="020B0604020202020204" pitchFamily="34" charset="0"/>
+            </a:endParaRPr>
+          </a:p>
+          <a:p>
+            <a:pPr>
+              <a:lnSpc>
+                <a:spcPct val="150000"/>
+              </a:lnSpc>
+              <a:buNone/>
+            </a:pPr>
+            <a:endParaRPr kumimoji="0" lang="en-US" altLang="en-US" sz="1300" b="0" i="0" u="none" strike="noStrike" cap="none" normalizeH="0" baseline="0">
+              <a:ln>
+                <a:noFill/>
+              </a:ln>
+              <a:solidFill>
+                <a:schemeClr val="tx1"/>
+              </a:solidFill>
+              <a:effectLst/>
+              <a:latin typeface="Arial" panose="020B0604020202020204" pitchFamily="34" charset="0"/>
+            </a:endParaRPr>
+          </a:p>
+          <a:p>
+            <a:pPr>
+              <a:lnSpc>
+                <a:spcPct val="150000"/>
+              </a:lnSpc>
+              <a:buNone/>
+            </a:pPr>
+            <a:endParaRPr lang="en-US" altLang="en-US" sz="1300">
+              <a:latin typeface="Arial" panose="020B0604020202020204" pitchFamily="34" charset="0"/>
+            </a:endParaRPr>
+          </a:p>
+          <a:p>
+            <a:pPr>
+              <a:lnSpc>
+                <a:spcPct val="150000"/>
+              </a:lnSpc>
+              <a:buNone/>
+            </a:pPr>
+            <a:r>
+              <a:rPr lang="en-US" altLang="en-US" sz="1300">
+                <a:latin typeface="Arial" panose="020B0604020202020204" pitchFamily="34" charset="0"/>
+              </a:rPr>
+              <a:t>1. Controller-dən göndərmək (ən sadə və məsləhətli yol)</a:t>
+            </a:r>
+          </a:p>
+          <a:p>
+            <a:pPr>
+              <a:lnSpc>
+                <a:spcPct val="150000"/>
+              </a:lnSpc>
+              <a:buNone/>
+            </a:pPr>
+            <a:r>
+              <a:rPr lang="en-US" altLang="en-US" sz="1300">
+                <a:latin typeface="Arial" panose="020B0604020202020204" pitchFamily="34" charset="0"/>
+              </a:rPr>
+              <a:t>Məsələn HomeController-də:</a:t>
+            </a:r>
+          </a:p>
+          <a:p>
+            <a:pPr>
+              <a:lnSpc>
+                <a:spcPct val="150000"/>
+              </a:lnSpc>
+              <a:buNone/>
+            </a:pPr>
+            <a:endParaRPr kumimoji="0" lang="en-US" altLang="en-US" sz="1300" b="0" i="0" u="none" strike="noStrike" cap="none" normalizeH="0" baseline="0">
+              <a:ln>
+                <a:noFill/>
+              </a:ln>
+              <a:solidFill>
+                <a:schemeClr val="tx1"/>
+              </a:solidFill>
+              <a:effectLst/>
+              <a:latin typeface="Arial" panose="020B0604020202020204" pitchFamily="34" charset="0"/>
+            </a:endParaRPr>
+          </a:p>
+          <a:p>
+            <a:pPr>
+              <a:lnSpc>
+                <a:spcPct val="150000"/>
+              </a:lnSpc>
+              <a:buNone/>
+            </a:pPr>
+            <a:endParaRPr lang="en-US" altLang="en-US" sz="1300">
+              <a:latin typeface="Arial" panose="020B0604020202020204" pitchFamily="34" charset="0"/>
+            </a:endParaRPr>
+          </a:p>
+          <a:p>
+            <a:pPr>
+              <a:lnSpc>
+                <a:spcPct val="150000"/>
+              </a:lnSpc>
+              <a:buNone/>
+            </a:pPr>
+            <a:endParaRPr kumimoji="0" lang="en-US" altLang="en-US" sz="1300" b="0" i="0" u="none" strike="noStrike" cap="none" normalizeH="0" baseline="0">
+              <a:ln>
+                <a:noFill/>
+              </a:ln>
+              <a:solidFill>
+                <a:schemeClr val="tx1"/>
+              </a:solidFill>
+              <a:effectLst/>
+              <a:latin typeface="Arial" panose="020B0604020202020204" pitchFamily="34" charset="0"/>
+            </a:endParaRPr>
+          </a:p>
+          <a:p>
+            <a:pPr>
+              <a:lnSpc>
+                <a:spcPct val="150000"/>
+              </a:lnSpc>
+              <a:buNone/>
+            </a:pPr>
+            <a:endParaRPr lang="en-US" altLang="en-US" sz="1300">
+              <a:latin typeface="Arial" panose="020B0604020202020204" pitchFamily="34" charset="0"/>
+            </a:endParaRPr>
+          </a:p>
+          <a:p>
+            <a:pPr>
+              <a:lnSpc>
+                <a:spcPct val="150000"/>
+              </a:lnSpc>
+              <a:buNone/>
+            </a:pPr>
+            <a:endParaRPr kumimoji="0" lang="en-US" altLang="en-US" sz="1300" b="0" i="0" u="none" strike="noStrike" cap="none" normalizeH="0" baseline="0">
+              <a:ln>
+                <a:noFill/>
+              </a:ln>
+              <a:solidFill>
+                <a:schemeClr val="tx1"/>
+              </a:solidFill>
+              <a:effectLst/>
+              <a:latin typeface="Arial" panose="020B0604020202020204" pitchFamily="34" charset="0"/>
+            </a:endParaRPr>
+          </a:p>
+          <a:p>
+            <a:pPr>
+              <a:lnSpc>
+                <a:spcPct val="150000"/>
+              </a:lnSpc>
+              <a:buNone/>
+            </a:pPr>
+            <a:endParaRPr lang="en-US" altLang="en-US" sz="1300">
+              <a:latin typeface="Arial" panose="020B0604020202020204" pitchFamily="34" charset="0"/>
+            </a:endParaRPr>
+          </a:p>
+          <a:p>
+            <a:pPr>
+              <a:lnSpc>
+                <a:spcPct val="150000"/>
+              </a:lnSpc>
+              <a:buNone/>
+            </a:pPr>
+            <a:r>
+              <a:rPr lang="en-US" altLang="en-US" sz="1300">
+                <a:latin typeface="Arial" panose="020B0604020202020204" pitchFamily="34" charset="0"/>
+              </a:rPr>
+              <a:t>✅ Bu yol ən çox istifadə olunan və təmiz yanaşmadır.</a:t>
+            </a:r>
+          </a:p>
+          <a:p>
+            <a:pPr>
+              <a:lnSpc>
+                <a:spcPct val="150000"/>
+              </a:lnSpc>
+              <a:buNone/>
+            </a:pPr>
+            <a:r>
+              <a:rPr lang="en-US" altLang="en-US" sz="1300">
+                <a:latin typeface="Arial" panose="020B0604020202020204" pitchFamily="34" charset="0"/>
+              </a:rPr>
+              <a:t>❌ Amma hər səhifədə $categories lazım olacaqsa, hər kontrollerdə </a:t>
+            </a:r>
+          </a:p>
+          <a:p>
+            <a:pPr>
+              <a:lnSpc>
+                <a:spcPct val="150000"/>
+              </a:lnSpc>
+              <a:buNone/>
+            </a:pPr>
+            <a:r>
+              <a:rPr lang="en-US" altLang="en-US" sz="1300">
+                <a:latin typeface="Arial" panose="020B0604020202020204" pitchFamily="34" charset="0"/>
+              </a:rPr>
+              <a:t>yenidən yazmalı olursan.</a:t>
+            </a:r>
+            <a:endParaRPr kumimoji="0" lang="en-US" altLang="en-US" sz="1300" b="0" i="0" u="none" strike="noStrike" cap="none" normalizeH="0" baseline="0">
+              <a:ln>
+                <a:noFill/>
+              </a:ln>
+              <a:solidFill>
+                <a:schemeClr val="tx1"/>
+              </a:solidFill>
+              <a:effectLst/>
+              <a:latin typeface="Arial" panose="020B0604020202020204" pitchFamily="34" charset="0"/>
+            </a:endParaRPr>
+          </a:p>
+        </p:txBody>
+      </p:sp>
+      <p:pic>
+        <p:nvPicPr>
+          <p:cNvPr id="4" name="Picture 3">
+            <a:extLst>
+              <a:ext uri="{FF2B5EF4-FFF2-40B4-BE49-F238E27FC236}">
+                <a16:creationId xmlns:a16="http://schemas.microsoft.com/office/drawing/2014/main" id="{461EA279-727F-5403-AE69-D7D4A1C4E05F}"/>
+              </a:ext>
+            </a:extLst>
+          </p:cNvPr>
+          <p:cNvPicPr>
+            <a:picLocks noChangeAspect="1"/>
+          </p:cNvPicPr>
+          <p:nvPr/>
+        </p:nvPicPr>
+        <p:blipFill>
+          <a:blip r:embed="rId2"/>
+          <a:stretch>
+            <a:fillRect/>
+          </a:stretch>
+        </p:blipFill>
+        <p:spPr>
+          <a:xfrm>
+            <a:off x="6096000" y="2349819"/>
+            <a:ext cx="6096000" cy="4508181"/>
+          </a:xfrm>
+          <a:prstGeom prst="rect">
+            <a:avLst/>
+          </a:prstGeom>
+        </p:spPr>
+      </p:pic>
+      <p:pic>
+        <p:nvPicPr>
+          <p:cNvPr id="7" name="Picture 6">
+            <a:extLst>
+              <a:ext uri="{FF2B5EF4-FFF2-40B4-BE49-F238E27FC236}">
+                <a16:creationId xmlns:a16="http://schemas.microsoft.com/office/drawing/2014/main" id="{6A7A56F8-0D10-CB47-AFBF-929757C10075}"/>
+              </a:ext>
+            </a:extLst>
+          </p:cNvPr>
+          <p:cNvPicPr>
+            <a:picLocks noChangeAspect="1"/>
+          </p:cNvPicPr>
+          <p:nvPr/>
+        </p:nvPicPr>
+        <p:blipFill>
+          <a:blip r:embed="rId3"/>
+          <a:stretch>
+            <a:fillRect/>
+          </a:stretch>
+        </p:blipFill>
+        <p:spPr>
+          <a:xfrm>
+            <a:off x="217714" y="2490989"/>
+            <a:ext cx="4982270" cy="1247949"/>
+          </a:xfrm>
+          <a:prstGeom prst="rect">
+            <a:avLst/>
+          </a:prstGeom>
+        </p:spPr>
+      </p:pic>
+    </p:spTree>
+    <p:extLst>
+      <p:ext uri="{BB962C8B-B14F-4D97-AF65-F5344CB8AC3E}">
+        <p14:creationId xmlns:p14="http://schemas.microsoft.com/office/powerpoint/2010/main" val="3282410845"/>
+      </p:ext>
+    </p:extLst>
+  </p:cSld>
+  <p:clrMapOvr>
+    <a:masterClrMapping/>
+  </p:clrMapOvr>
+</p:sld>
+</file>
+
+<file path=ppt/slides/slide6.xml><?xml version="1.0" encoding="utf-8"?>
+<p:sld xmlns:a="http://schemas.openxmlformats.org/drawingml/2006/main" xmlns:r="http://schemas.openxmlformats.org/officeDocument/2006/relationships" xmlns:p="http://schemas.openxmlformats.org/presentationml/2006/main">
+  <p:cSld>
+    <p:spTree>
+      <p:nvGrpSpPr>
+        <p:cNvPr id="1" name="">
+          <a:extLst>
+            <a:ext uri="{FF2B5EF4-FFF2-40B4-BE49-F238E27FC236}">
+              <a16:creationId xmlns:a16="http://schemas.microsoft.com/office/drawing/2014/main" id="{43055189-6759-7C6F-6520-FA5432EC2458}"/>
+            </a:ext>
+          </a:extLst>
+        </p:cNvPr>
+        <p:cNvGrpSpPr/>
+        <p:nvPr/>
+      </p:nvGrpSpPr>
+      <p:grpSpPr>
+        <a:xfrm>
+          <a:off x="0" y="0"/>
+          <a:ext cx="0" cy="0"/>
+          <a:chOff x="0" y="0"/>
+          <a:chExt cx="0" cy="0"/>
+        </a:xfrm>
+      </p:grpSpPr>
+      <p:sp>
+        <p:nvSpPr>
+          <p:cNvPr id="3" name="TextBox 2">
+            <a:extLst>
+              <a:ext uri="{FF2B5EF4-FFF2-40B4-BE49-F238E27FC236}">
+                <a16:creationId xmlns:a16="http://schemas.microsoft.com/office/drawing/2014/main" id="{EBBFB0FB-0CD5-698C-4BBD-C04CE5AFD936}"/>
+              </a:ext>
+            </a:extLst>
+          </p:cNvPr>
+          <p:cNvSpPr txBox="1"/>
+          <p:nvPr/>
+        </p:nvSpPr>
+        <p:spPr>
+          <a:xfrm>
+            <a:off x="217714" y="255046"/>
+            <a:ext cx="11756571" cy="5756769"/>
+          </a:xfrm>
+          <a:prstGeom prst="rect">
+            <a:avLst/>
+          </a:prstGeom>
+          <a:noFill/>
+        </p:spPr>
+        <p:txBody>
+          <a:bodyPr wrap="square">
+            <a:spAutoFit/>
+          </a:bodyPr>
+          <a:lstStyle/>
+          <a:p>
+            <a:pPr>
+              <a:lnSpc>
+                <a:spcPct val="150000"/>
+              </a:lnSpc>
+              <a:buNone/>
+            </a:pPr>
+            <a:r>
+              <a:rPr lang="en-US" altLang="en-US" sz="1300">
+                <a:latin typeface="Arial" panose="020B0604020202020204" pitchFamily="34" charset="0"/>
+              </a:rPr>
+              <a:t>2. View Composer ilə paylaşmaq (</a:t>
+            </a:r>
+            <a:r>
+              <a:rPr lang="en-US" altLang="en-US" sz="1300" b="1">
+                <a:latin typeface="Arial" panose="020B0604020202020204" pitchFamily="34" charset="0"/>
+              </a:rPr>
+              <a:t>qlobal</a:t>
+            </a:r>
+            <a:r>
+              <a:rPr lang="en-US" altLang="en-US" sz="1300">
+                <a:latin typeface="Arial" panose="020B0604020202020204" pitchFamily="34" charset="0"/>
+              </a:rPr>
+              <a:t> etmək)</a:t>
+            </a:r>
+          </a:p>
+          <a:p>
+            <a:pPr>
+              <a:lnSpc>
+                <a:spcPct val="150000"/>
+              </a:lnSpc>
+              <a:buNone/>
+            </a:pPr>
+            <a:endParaRPr lang="en-US" altLang="en-US" sz="1300">
+              <a:latin typeface="Arial" panose="020B0604020202020204" pitchFamily="34" charset="0"/>
+            </a:endParaRPr>
+          </a:p>
+          <a:p>
+            <a:pPr>
+              <a:lnSpc>
+                <a:spcPct val="150000"/>
+              </a:lnSpc>
+              <a:buNone/>
+            </a:pPr>
+            <a:r>
+              <a:rPr lang="en-US" altLang="en-US" sz="1300">
+                <a:latin typeface="Arial" panose="020B0604020202020204" pitchFamily="34" charset="0"/>
+              </a:rPr>
+              <a:t>Əgər hər səhifədə </a:t>
+            </a:r>
+            <a:r>
+              <a:rPr lang="en-US" altLang="en-US" sz="1300" b="1">
+                <a:latin typeface="Arial" panose="020B0604020202020204" pitchFamily="34" charset="0"/>
+              </a:rPr>
+              <a:t>menu.blade.php </a:t>
+            </a:r>
+            <a:r>
+              <a:rPr lang="en-US" altLang="en-US" sz="1300">
+                <a:latin typeface="Arial" panose="020B0604020202020204" pitchFamily="34" charset="0"/>
+              </a:rPr>
+              <a:t>istifadə olunursa, </a:t>
+            </a:r>
+            <a:r>
+              <a:rPr lang="en-US" altLang="en-US" sz="1300" b="1">
+                <a:latin typeface="Arial" panose="020B0604020202020204" pitchFamily="34" charset="0"/>
+              </a:rPr>
+              <a:t>$categories</a:t>
+            </a:r>
+            <a:r>
+              <a:rPr lang="en-US" altLang="en-US" sz="1300">
+                <a:latin typeface="Arial" panose="020B0604020202020204" pitchFamily="34" charset="0"/>
+              </a:rPr>
+              <a:t>-i hər kontrollerdə yazmaq əvəzinə, </a:t>
+            </a:r>
+            <a:r>
+              <a:rPr lang="en-US" altLang="en-US" sz="1300" b="1">
+                <a:latin typeface="Arial" panose="020B0604020202020204" pitchFamily="34" charset="0"/>
+              </a:rPr>
+              <a:t>View Composer </a:t>
+            </a:r>
+            <a:r>
+              <a:rPr lang="en-US" altLang="en-US" sz="1300">
+                <a:latin typeface="Arial" panose="020B0604020202020204" pitchFamily="34" charset="0"/>
+              </a:rPr>
+              <a:t>istifadə edə bilərsən.</a:t>
+            </a:r>
+          </a:p>
+          <a:p>
+            <a:pPr>
+              <a:lnSpc>
+                <a:spcPct val="150000"/>
+              </a:lnSpc>
+              <a:buNone/>
+            </a:pPr>
+            <a:endParaRPr lang="en-US" altLang="en-US" sz="1300">
+              <a:latin typeface="Arial" panose="020B0604020202020204" pitchFamily="34" charset="0"/>
+            </a:endParaRPr>
+          </a:p>
+          <a:p>
+            <a:pPr>
+              <a:lnSpc>
+                <a:spcPct val="150000"/>
+              </a:lnSpc>
+              <a:buNone/>
+            </a:pPr>
+            <a:r>
+              <a:rPr lang="en-US" altLang="en-US" sz="1300">
+                <a:latin typeface="Arial" panose="020B0604020202020204" pitchFamily="34" charset="0"/>
+              </a:rPr>
+              <a:t>App\Providers\AppServiceProvider.php → </a:t>
+            </a:r>
+            <a:r>
+              <a:rPr lang="en-US" altLang="en-US" sz="1300" b="1">
+                <a:latin typeface="Arial" panose="020B0604020202020204" pitchFamily="34" charset="0"/>
+              </a:rPr>
+              <a:t>boot() </a:t>
+            </a:r>
+            <a:r>
+              <a:rPr lang="en-US" altLang="en-US" sz="1300">
+                <a:latin typeface="Arial" panose="020B0604020202020204" pitchFamily="34" charset="0"/>
+              </a:rPr>
+              <a:t>metoduna yaz:</a:t>
+            </a:r>
+          </a:p>
+          <a:p>
+            <a:pPr>
+              <a:lnSpc>
+                <a:spcPct val="150000"/>
+              </a:lnSpc>
+              <a:buNone/>
+            </a:pPr>
+            <a:endParaRPr kumimoji="0" lang="en-US" altLang="en-US" sz="1300" b="0" i="0" u="none" strike="noStrike" cap="none" normalizeH="0" baseline="0">
+              <a:ln>
+                <a:noFill/>
+              </a:ln>
+              <a:solidFill>
+                <a:schemeClr val="tx1"/>
+              </a:solidFill>
+              <a:effectLst/>
+              <a:latin typeface="Arial" panose="020B0604020202020204" pitchFamily="34" charset="0"/>
+            </a:endParaRPr>
+          </a:p>
+          <a:p>
+            <a:pPr>
+              <a:lnSpc>
+                <a:spcPct val="150000"/>
+              </a:lnSpc>
+              <a:buNone/>
+            </a:pPr>
+            <a:endParaRPr lang="en-US" altLang="en-US" sz="1300">
+              <a:latin typeface="Arial" panose="020B0604020202020204" pitchFamily="34" charset="0"/>
+            </a:endParaRPr>
+          </a:p>
+          <a:p>
+            <a:pPr>
+              <a:lnSpc>
+                <a:spcPct val="150000"/>
+              </a:lnSpc>
+              <a:buNone/>
+            </a:pPr>
+            <a:endParaRPr kumimoji="0" lang="en-US" altLang="en-US" sz="1300" b="0" i="0" u="none" strike="noStrike" cap="none" normalizeH="0" baseline="0">
+              <a:ln>
+                <a:noFill/>
+              </a:ln>
+              <a:solidFill>
+                <a:schemeClr val="tx1"/>
+              </a:solidFill>
+              <a:effectLst/>
+              <a:latin typeface="Arial" panose="020B0604020202020204" pitchFamily="34" charset="0"/>
+            </a:endParaRPr>
+          </a:p>
+          <a:p>
+            <a:pPr>
+              <a:lnSpc>
+                <a:spcPct val="150000"/>
+              </a:lnSpc>
+              <a:buNone/>
+            </a:pPr>
+            <a:endParaRPr lang="en-US" altLang="en-US" sz="1300">
+              <a:latin typeface="Arial" panose="020B0604020202020204" pitchFamily="34" charset="0"/>
+            </a:endParaRPr>
+          </a:p>
+          <a:p>
+            <a:pPr>
+              <a:lnSpc>
+                <a:spcPct val="150000"/>
+              </a:lnSpc>
+              <a:buNone/>
+            </a:pPr>
+            <a:endParaRPr kumimoji="0" lang="en-US" altLang="en-US" sz="1300" b="0" i="0" u="none" strike="noStrike" cap="none" normalizeH="0" baseline="0">
+              <a:ln>
+                <a:noFill/>
+              </a:ln>
+              <a:solidFill>
+                <a:schemeClr val="tx1"/>
+              </a:solidFill>
+              <a:effectLst/>
+              <a:latin typeface="Arial" panose="020B0604020202020204" pitchFamily="34" charset="0"/>
+            </a:endParaRPr>
+          </a:p>
+          <a:p>
+            <a:pPr>
+              <a:lnSpc>
+                <a:spcPct val="150000"/>
+              </a:lnSpc>
+              <a:buNone/>
+            </a:pPr>
+            <a:endParaRPr lang="en-US" altLang="en-US" sz="1300">
+              <a:latin typeface="Arial" panose="020B0604020202020204" pitchFamily="34" charset="0"/>
+            </a:endParaRPr>
+          </a:p>
+          <a:p>
+            <a:pPr>
+              <a:lnSpc>
+                <a:spcPct val="150000"/>
+              </a:lnSpc>
+              <a:buNone/>
+            </a:pPr>
+            <a:endParaRPr kumimoji="0" lang="en-US" altLang="en-US" sz="1300" b="0" i="0" u="none" strike="noStrike" cap="none" normalizeH="0" baseline="0">
+              <a:ln>
+                <a:noFill/>
+              </a:ln>
+              <a:solidFill>
+                <a:schemeClr val="tx1"/>
+              </a:solidFill>
+              <a:effectLst/>
+              <a:latin typeface="Arial" panose="020B0604020202020204" pitchFamily="34" charset="0"/>
+            </a:endParaRPr>
+          </a:p>
+          <a:p>
+            <a:pPr>
+              <a:lnSpc>
+                <a:spcPct val="150000"/>
+              </a:lnSpc>
+              <a:buNone/>
+            </a:pPr>
+            <a:endParaRPr lang="en-US" altLang="en-US" sz="1300">
+              <a:latin typeface="Arial" panose="020B0604020202020204" pitchFamily="34" charset="0"/>
+            </a:endParaRPr>
+          </a:p>
+          <a:p>
+            <a:pPr>
+              <a:lnSpc>
+                <a:spcPct val="150000"/>
+              </a:lnSpc>
+              <a:buNone/>
+            </a:pPr>
+            <a:endParaRPr kumimoji="0" lang="en-US" altLang="en-US" sz="1300" b="0" i="0" u="none" strike="noStrike" cap="none" normalizeH="0" baseline="0">
+              <a:ln>
+                <a:noFill/>
+              </a:ln>
+              <a:solidFill>
+                <a:schemeClr val="tx1"/>
+              </a:solidFill>
+              <a:effectLst/>
+              <a:latin typeface="Arial" panose="020B0604020202020204" pitchFamily="34" charset="0"/>
+            </a:endParaRPr>
+          </a:p>
+          <a:p>
+            <a:pPr>
+              <a:lnSpc>
+                <a:spcPct val="150000"/>
+              </a:lnSpc>
+              <a:buNone/>
+            </a:pPr>
+            <a:r>
+              <a:rPr lang="en-US" altLang="en-US" sz="1300">
+                <a:latin typeface="Arial" panose="020B0604020202020204" pitchFamily="34" charset="0"/>
+              </a:rPr>
+              <a:t>Bununla artıq menu.blade.php faylına </a:t>
+            </a:r>
+            <a:r>
+              <a:rPr lang="en-US" altLang="en-US" sz="1300" b="1">
+                <a:latin typeface="Arial" panose="020B0604020202020204" pitchFamily="34" charset="0"/>
+              </a:rPr>
+              <a:t>$categories </a:t>
+            </a:r>
+            <a:r>
+              <a:rPr lang="en-US" altLang="en-US" sz="1300">
+                <a:latin typeface="Arial" panose="020B0604020202020204" pitchFamily="34" charset="0"/>
+              </a:rPr>
+              <a:t>avtomatik ötürüləcək.</a:t>
+            </a:r>
+          </a:p>
+          <a:p>
+            <a:pPr>
+              <a:lnSpc>
+                <a:spcPct val="150000"/>
+              </a:lnSpc>
+              <a:buNone/>
+            </a:pPr>
+            <a:endParaRPr lang="en-US" altLang="en-US" sz="1300">
+              <a:latin typeface="Arial" panose="020B0604020202020204" pitchFamily="34" charset="0"/>
+            </a:endParaRPr>
+          </a:p>
+          <a:p>
+            <a:pPr>
+              <a:lnSpc>
+                <a:spcPct val="150000"/>
+              </a:lnSpc>
+              <a:buNone/>
+            </a:pPr>
+            <a:r>
+              <a:rPr lang="en-US" altLang="en-US" sz="1300">
+                <a:latin typeface="Arial" panose="020B0604020202020204" pitchFamily="34" charset="0"/>
+              </a:rPr>
+              <a:t>✅ Yüksək səviyyədə professional və dəqiq yol.</a:t>
+            </a:r>
+          </a:p>
+          <a:p>
+            <a:pPr>
+              <a:lnSpc>
+                <a:spcPct val="150000"/>
+              </a:lnSpc>
+              <a:buNone/>
+            </a:pPr>
+            <a:r>
+              <a:rPr lang="en-US" altLang="en-US" sz="1300">
+                <a:latin typeface="Arial" panose="020B0604020202020204" pitchFamily="34" charset="0"/>
+              </a:rPr>
+              <a:t>✅ Hər kontrollerdə əlavə kod yazmağa ehtiyac yoxdur.</a:t>
+            </a:r>
+          </a:p>
+          <a:p>
+            <a:pPr>
+              <a:lnSpc>
+                <a:spcPct val="150000"/>
+              </a:lnSpc>
+              <a:buNone/>
+            </a:pPr>
+            <a:r>
+              <a:rPr lang="en-US" altLang="en-US" sz="1300">
+                <a:latin typeface="Arial" panose="020B0604020202020204" pitchFamily="34" charset="0"/>
+              </a:rPr>
+              <a:t>❌ Amma çox böyük layihələrdə hər səhifədə </a:t>
+            </a:r>
+            <a:r>
+              <a:rPr lang="en-US" altLang="en-US" sz="1300" b="1">
+                <a:latin typeface="Arial" panose="020B0604020202020204" pitchFamily="34" charset="0"/>
+              </a:rPr>
+              <a:t>$categories </a:t>
+            </a:r>
+            <a:r>
+              <a:rPr lang="en-US" altLang="en-US" sz="1300">
+                <a:latin typeface="Arial" panose="020B0604020202020204" pitchFamily="34" charset="0"/>
+              </a:rPr>
+              <a:t>yüklənməsi əlavə query ola bilər (</a:t>
+            </a:r>
+            <a:r>
+              <a:rPr lang="en-US" altLang="en-US" sz="1300" b="1">
+                <a:latin typeface="Arial" panose="020B0604020202020204" pitchFamily="34" charset="0"/>
+              </a:rPr>
+              <a:t>caching</a:t>
+            </a:r>
+            <a:r>
+              <a:rPr lang="en-US" altLang="en-US" sz="1300">
+                <a:latin typeface="Arial" panose="020B0604020202020204" pitchFamily="34" charset="0"/>
+              </a:rPr>
+              <a:t> istifadə etmək olar).</a:t>
+            </a:r>
+            <a:endParaRPr kumimoji="0" lang="en-US" altLang="en-US" sz="1300" b="0" i="0" u="none" strike="noStrike" cap="none" normalizeH="0" baseline="0">
+              <a:ln>
+                <a:noFill/>
+              </a:ln>
+              <a:solidFill>
+                <a:schemeClr val="tx1"/>
+              </a:solidFill>
+              <a:effectLst/>
+              <a:latin typeface="Arial" panose="020B0604020202020204" pitchFamily="34" charset="0"/>
+            </a:endParaRPr>
+          </a:p>
+        </p:txBody>
+      </p:sp>
+      <p:pic>
+        <p:nvPicPr>
+          <p:cNvPr id="4" name="Picture 3">
+            <a:extLst>
+              <a:ext uri="{FF2B5EF4-FFF2-40B4-BE49-F238E27FC236}">
+                <a16:creationId xmlns:a16="http://schemas.microsoft.com/office/drawing/2014/main" id="{1C84F045-B687-91AC-69A5-4174D6EBAA3E}"/>
+              </a:ext>
+            </a:extLst>
+          </p:cNvPr>
+          <p:cNvPicPr>
+            <a:picLocks noChangeAspect="1"/>
+          </p:cNvPicPr>
+          <p:nvPr/>
+        </p:nvPicPr>
+        <p:blipFill>
+          <a:blip r:embed="rId2"/>
+          <a:stretch>
+            <a:fillRect/>
+          </a:stretch>
+        </p:blipFill>
+        <p:spPr>
+          <a:xfrm>
+            <a:off x="217714" y="1940491"/>
+            <a:ext cx="4820323" cy="2219635"/>
+          </a:xfrm>
+          <a:prstGeom prst="rect">
+            <a:avLst/>
+          </a:prstGeom>
+        </p:spPr>
+      </p:pic>
+    </p:spTree>
+    <p:extLst>
+      <p:ext uri="{BB962C8B-B14F-4D97-AF65-F5344CB8AC3E}">
+        <p14:creationId xmlns:p14="http://schemas.microsoft.com/office/powerpoint/2010/main" val="3248820881"/>
+      </p:ext>
+    </p:extLst>
+  </p:cSld>
+  <p:clrMapOvr>
+    <a:masterClrMapping/>
+  </p:clrMapOvr>
+</p:sld>
+</file>
+
+<file path=ppt/slides/slide7.xml><?xml version="1.0" encoding="utf-8"?>
+<p:sld xmlns:a="http://schemas.openxmlformats.org/drawingml/2006/main" xmlns:r="http://schemas.openxmlformats.org/officeDocument/2006/relationships" xmlns:p="http://schemas.openxmlformats.org/presentationml/2006/main">
+  <p:cSld>
+    <p:spTree>
+      <p:nvGrpSpPr>
+        <p:cNvPr id="1" name="">
+          <a:extLst>
+            <a:ext uri="{FF2B5EF4-FFF2-40B4-BE49-F238E27FC236}">
+              <a16:creationId xmlns:a16="http://schemas.microsoft.com/office/drawing/2014/main" id="{00068E32-95C3-0B1F-F97C-2031F73B7BF0}"/>
+            </a:ext>
+          </a:extLst>
+        </p:cNvPr>
+        <p:cNvGrpSpPr/>
+        <p:nvPr/>
+      </p:nvGrpSpPr>
+      <p:grpSpPr>
+        <a:xfrm>
+          <a:off x="0" y="0"/>
+          <a:ext cx="0" cy="0"/>
+          <a:chOff x="0" y="0"/>
+          <a:chExt cx="0" cy="0"/>
+        </a:xfrm>
+      </p:grpSpPr>
+      <p:sp>
+        <p:nvSpPr>
+          <p:cNvPr id="3" name="TextBox 2">
+            <a:extLst>
+              <a:ext uri="{FF2B5EF4-FFF2-40B4-BE49-F238E27FC236}">
+                <a16:creationId xmlns:a16="http://schemas.microsoft.com/office/drawing/2014/main" id="{C3CC415E-F57E-1496-C1A6-88D8705C11FB}"/>
+              </a:ext>
+            </a:extLst>
+          </p:cNvPr>
+          <p:cNvSpPr txBox="1"/>
+          <p:nvPr/>
+        </p:nvSpPr>
+        <p:spPr>
+          <a:xfrm>
+            <a:off x="217714" y="255046"/>
+            <a:ext cx="11756571" cy="4556440"/>
+          </a:xfrm>
+          <a:prstGeom prst="rect">
+            <a:avLst/>
+          </a:prstGeom>
+          <a:noFill/>
+        </p:spPr>
+        <p:txBody>
+          <a:bodyPr wrap="square">
+            <a:spAutoFit/>
+          </a:bodyPr>
+          <a:lstStyle/>
+          <a:p>
+            <a:pPr>
+              <a:lnSpc>
+                <a:spcPct val="150000"/>
+              </a:lnSpc>
+              <a:buNone/>
+            </a:pPr>
+            <a:r>
+              <a:rPr lang="en-US" altLang="en-US" sz="1300">
+                <a:latin typeface="Arial" panose="020B0604020202020204" pitchFamily="34" charset="0"/>
+              </a:rPr>
+              <a:t>3. Service Provider ilə paylaşmaq (bütün view-lərə)</a:t>
+            </a:r>
+          </a:p>
+          <a:p>
+            <a:pPr>
+              <a:lnSpc>
+                <a:spcPct val="150000"/>
+              </a:lnSpc>
+              <a:buNone/>
+            </a:pPr>
+            <a:endParaRPr lang="en-US" altLang="en-US" sz="1300">
+              <a:latin typeface="Arial" panose="020B0604020202020204" pitchFamily="34" charset="0"/>
+            </a:endParaRPr>
+          </a:p>
+          <a:p>
+            <a:pPr>
+              <a:lnSpc>
+                <a:spcPct val="150000"/>
+              </a:lnSpc>
+              <a:buNone/>
+            </a:pPr>
+            <a:r>
+              <a:rPr lang="en-US" altLang="en-US" sz="1300">
+                <a:latin typeface="Arial" panose="020B0604020202020204" pitchFamily="34" charset="0"/>
+              </a:rPr>
+              <a:t>Əgər </a:t>
+            </a:r>
+            <a:r>
+              <a:rPr lang="en-US" altLang="en-US" sz="1300" b="1">
+                <a:latin typeface="Arial" panose="020B0604020202020204" pitchFamily="34" charset="0"/>
+              </a:rPr>
+              <a:t>$categories </a:t>
+            </a:r>
+            <a:r>
+              <a:rPr lang="en-US" altLang="en-US" sz="1300">
+                <a:latin typeface="Arial" panose="020B0604020202020204" pitchFamily="34" charset="0"/>
+              </a:rPr>
+              <a:t>hər yerdə lazım olacaqsa, bütün </a:t>
+            </a:r>
+            <a:r>
+              <a:rPr lang="en-US" altLang="en-US" sz="1300" b="1">
+                <a:latin typeface="Arial" panose="020B0604020202020204" pitchFamily="34" charset="0"/>
+              </a:rPr>
+              <a:t>view</a:t>
+            </a:r>
+            <a:r>
+              <a:rPr lang="en-US" altLang="en-US" sz="1300">
+                <a:latin typeface="Arial" panose="020B0604020202020204" pitchFamily="34" charset="0"/>
+              </a:rPr>
+              <a:t>-lərə göndərə bilərsən:</a:t>
+            </a:r>
+          </a:p>
+          <a:p>
+            <a:pPr>
+              <a:lnSpc>
+                <a:spcPct val="150000"/>
+              </a:lnSpc>
+              <a:buNone/>
+            </a:pPr>
+            <a:endParaRPr kumimoji="0" lang="en-US" altLang="en-US" sz="1300" b="0" i="0" u="none" strike="noStrike" cap="none" normalizeH="0" baseline="0">
+              <a:ln>
+                <a:noFill/>
+              </a:ln>
+              <a:solidFill>
+                <a:schemeClr val="tx1"/>
+              </a:solidFill>
+              <a:effectLst/>
+              <a:latin typeface="Arial" panose="020B0604020202020204" pitchFamily="34" charset="0"/>
+            </a:endParaRPr>
+          </a:p>
+          <a:p>
+            <a:pPr>
+              <a:lnSpc>
+                <a:spcPct val="150000"/>
+              </a:lnSpc>
+              <a:buNone/>
+            </a:pPr>
+            <a:endParaRPr lang="en-US" altLang="en-US" sz="1300">
+              <a:latin typeface="Arial" panose="020B0604020202020204" pitchFamily="34" charset="0"/>
+            </a:endParaRPr>
+          </a:p>
+          <a:p>
+            <a:pPr>
+              <a:lnSpc>
+                <a:spcPct val="150000"/>
+              </a:lnSpc>
+              <a:buNone/>
+            </a:pPr>
+            <a:endParaRPr kumimoji="0" lang="en-US" altLang="en-US" sz="1300" b="0" i="0" u="none" strike="noStrike" cap="none" normalizeH="0" baseline="0">
+              <a:ln>
+                <a:noFill/>
+              </a:ln>
+              <a:solidFill>
+                <a:schemeClr val="tx1"/>
+              </a:solidFill>
+              <a:effectLst/>
+              <a:latin typeface="Arial" panose="020B0604020202020204" pitchFamily="34" charset="0"/>
+            </a:endParaRPr>
+          </a:p>
+          <a:p>
+            <a:pPr>
+              <a:lnSpc>
+                <a:spcPct val="150000"/>
+              </a:lnSpc>
+              <a:buNone/>
+            </a:pPr>
+            <a:endParaRPr lang="en-US" altLang="en-US" sz="1300">
+              <a:latin typeface="Arial" panose="020B0604020202020204" pitchFamily="34" charset="0"/>
+            </a:endParaRPr>
+          </a:p>
+          <a:p>
+            <a:pPr>
+              <a:lnSpc>
+                <a:spcPct val="150000"/>
+              </a:lnSpc>
+              <a:buNone/>
+            </a:pPr>
+            <a:endParaRPr kumimoji="0" lang="en-US" altLang="en-US" sz="1300" b="0" i="0" u="none" strike="noStrike" cap="none" normalizeH="0" baseline="0">
+              <a:ln>
+                <a:noFill/>
+              </a:ln>
+              <a:solidFill>
+                <a:schemeClr val="tx1"/>
+              </a:solidFill>
+              <a:effectLst/>
+              <a:latin typeface="Arial" panose="020B0604020202020204" pitchFamily="34" charset="0"/>
+            </a:endParaRPr>
+          </a:p>
+          <a:p>
+            <a:pPr>
+              <a:lnSpc>
+                <a:spcPct val="150000"/>
+              </a:lnSpc>
+              <a:buNone/>
+            </a:pPr>
+            <a:endParaRPr lang="en-US" altLang="en-US" sz="1300">
+              <a:latin typeface="Arial" panose="020B0604020202020204" pitchFamily="34" charset="0"/>
+            </a:endParaRPr>
+          </a:p>
+          <a:p>
+            <a:pPr>
+              <a:lnSpc>
+                <a:spcPct val="150000"/>
+              </a:lnSpc>
+              <a:buNone/>
+            </a:pPr>
+            <a:endParaRPr kumimoji="0" lang="en-US" altLang="en-US" sz="1300" b="0" i="0" u="none" strike="noStrike" cap="none" normalizeH="0" baseline="0">
+              <a:ln>
+                <a:noFill/>
+              </a:ln>
+              <a:solidFill>
+                <a:schemeClr val="tx1"/>
+              </a:solidFill>
+              <a:effectLst/>
+              <a:latin typeface="Arial" panose="020B0604020202020204" pitchFamily="34" charset="0"/>
+            </a:endParaRPr>
+          </a:p>
+          <a:p>
+            <a:pPr>
+              <a:lnSpc>
+                <a:spcPct val="150000"/>
+              </a:lnSpc>
+              <a:buNone/>
+            </a:pPr>
+            <a:endParaRPr lang="en-US" altLang="en-US" sz="1300">
+              <a:latin typeface="Arial" panose="020B0604020202020204" pitchFamily="34" charset="0"/>
+            </a:endParaRPr>
+          </a:p>
+          <a:p>
+            <a:pPr>
+              <a:lnSpc>
+                <a:spcPct val="150000"/>
+              </a:lnSpc>
+              <a:buNone/>
+            </a:pPr>
+            <a:r>
+              <a:rPr lang="en-US" altLang="en-US" sz="1300">
+                <a:latin typeface="Arial" panose="020B0604020202020204" pitchFamily="34" charset="0"/>
+              </a:rPr>
+              <a:t>Bu halda artıq hər view içində </a:t>
+            </a:r>
+            <a:r>
+              <a:rPr lang="en-US" altLang="en-US" sz="1300" b="1">
+                <a:latin typeface="Arial" panose="020B0604020202020204" pitchFamily="34" charset="0"/>
+              </a:rPr>
+              <a:t>$categories </a:t>
+            </a:r>
+            <a:r>
+              <a:rPr lang="en-US" altLang="en-US" sz="1300">
+                <a:latin typeface="Arial" panose="020B0604020202020204" pitchFamily="34" charset="0"/>
+              </a:rPr>
+              <a:t>olacaq.</a:t>
+            </a:r>
+          </a:p>
+          <a:p>
+            <a:pPr>
+              <a:lnSpc>
+                <a:spcPct val="150000"/>
+              </a:lnSpc>
+              <a:buNone/>
+            </a:pPr>
+            <a:endParaRPr lang="en-US" altLang="en-US" sz="1300">
+              <a:latin typeface="Arial" panose="020B0604020202020204" pitchFamily="34" charset="0"/>
+            </a:endParaRPr>
+          </a:p>
+          <a:p>
+            <a:pPr>
+              <a:lnSpc>
+                <a:spcPct val="150000"/>
+              </a:lnSpc>
+              <a:buNone/>
+            </a:pPr>
+            <a:r>
+              <a:rPr lang="en-US" altLang="en-US" sz="1300">
+                <a:latin typeface="Arial" panose="020B0604020202020204" pitchFamily="34" charset="0"/>
+              </a:rPr>
+              <a:t>✅ Ən sadə variantdır.</a:t>
+            </a:r>
+          </a:p>
+          <a:p>
+            <a:pPr>
+              <a:lnSpc>
+                <a:spcPct val="150000"/>
+              </a:lnSpc>
+              <a:buNone/>
+            </a:pPr>
+            <a:r>
+              <a:rPr lang="en-US" altLang="en-US" sz="1300">
+                <a:latin typeface="Arial" panose="020B0604020202020204" pitchFamily="34" charset="0"/>
+              </a:rPr>
+              <a:t>❌ Amma çox istifadə edildikdə lazımsız query-lərə səbəb ola bilər.</a:t>
+            </a:r>
+            <a:endParaRPr kumimoji="0" lang="en-US" altLang="en-US" sz="1300" b="0" i="0" u="none" strike="noStrike" cap="none" normalizeH="0" baseline="0">
+              <a:ln>
+                <a:noFill/>
+              </a:ln>
+              <a:solidFill>
+                <a:schemeClr val="tx1"/>
+              </a:solidFill>
+              <a:effectLst/>
+              <a:latin typeface="Arial" panose="020B0604020202020204" pitchFamily="34" charset="0"/>
+            </a:endParaRPr>
+          </a:p>
+        </p:txBody>
+      </p:sp>
+      <p:pic>
+        <p:nvPicPr>
+          <p:cNvPr id="4" name="Picture 3">
+            <a:extLst>
+              <a:ext uri="{FF2B5EF4-FFF2-40B4-BE49-F238E27FC236}">
+                <a16:creationId xmlns:a16="http://schemas.microsoft.com/office/drawing/2014/main" id="{4793EE8A-1006-2AD7-AE18-64DE40CC93CD}"/>
+              </a:ext>
+            </a:extLst>
+          </p:cNvPr>
+          <p:cNvPicPr>
+            <a:picLocks noChangeAspect="1"/>
+          </p:cNvPicPr>
+          <p:nvPr/>
+        </p:nvPicPr>
+        <p:blipFill>
+          <a:blip r:embed="rId2"/>
+          <a:stretch>
+            <a:fillRect/>
+          </a:stretch>
+        </p:blipFill>
+        <p:spPr>
+          <a:xfrm>
+            <a:off x="217714" y="1393559"/>
+            <a:ext cx="3677163" cy="1743318"/>
+          </a:xfrm>
+          <a:prstGeom prst="rect">
+            <a:avLst/>
+          </a:prstGeom>
+        </p:spPr>
+      </p:pic>
+    </p:spTree>
+    <p:extLst>
+      <p:ext uri="{BB962C8B-B14F-4D97-AF65-F5344CB8AC3E}">
+        <p14:creationId xmlns:p14="http://schemas.microsoft.com/office/powerpoint/2010/main" val="3377297035"/>
+      </p:ext>
+    </p:extLst>
+  </p:cSld>
+  <p:clrMapOvr>
+    <a:masterClrMapping/>
+  </p:clrMapOvr>
+</p:sld>
+</file>
+
+<file path=ppt/slides/slide8.xml><?xml version="1.0" encoding="utf-8"?>
 <p:sld xmlns:a="http://schemas.openxmlformats.org/drawingml/2006/main" xmlns:r="http://schemas.openxmlformats.org/officeDocument/2006/relationships" xmlns:p="http://schemas.openxmlformats.org/presentationml/2006/main">
   <p:cSld>
     <p:spTree>
@@ -3521,6 +5916,278 @@
         <p:spPr>
           <a:xfrm>
             <a:off x="217714" y="255046"/>
+            <a:ext cx="11756571" cy="3056093"/>
+          </a:xfrm>
+          <a:prstGeom prst="rect">
+            <a:avLst/>
+          </a:prstGeom>
+          <a:noFill/>
+        </p:spPr>
+        <p:txBody>
+          <a:bodyPr wrap="square">
+            <a:spAutoFit/>
+          </a:bodyPr>
+          <a:lstStyle/>
+          <a:p>
+            <a:pPr>
+              <a:lnSpc>
+                <a:spcPct val="150000"/>
+              </a:lnSpc>
+              <a:buNone/>
+            </a:pPr>
+            <a:r>
+              <a:rPr lang="en-US" altLang="en-US" sz="1300" b="1">
+                <a:latin typeface="Arial" panose="020B0604020202020204" pitchFamily="34" charset="0"/>
+              </a:rPr>
+              <a:t>Nəticə</a:t>
+            </a:r>
+            <a:r>
+              <a:rPr lang="en-US" altLang="en-US" sz="1300">
+                <a:latin typeface="Arial" panose="020B0604020202020204" pitchFamily="34" charset="0"/>
+              </a:rPr>
+              <a:t>:</a:t>
+            </a:r>
+          </a:p>
+          <a:p>
+            <a:pPr>
+              <a:lnSpc>
+                <a:spcPct val="150000"/>
+              </a:lnSpc>
+              <a:buNone/>
+            </a:pPr>
+            <a:endParaRPr lang="en-US" altLang="en-US" sz="1300">
+              <a:latin typeface="Arial" panose="020B0604020202020204" pitchFamily="34" charset="0"/>
+            </a:endParaRPr>
+          </a:p>
+          <a:p>
+            <a:pPr marL="285750" indent="-285750">
+              <a:lnSpc>
+                <a:spcPct val="150000"/>
+              </a:lnSpc>
+              <a:buFont typeface="Arial" panose="020B0604020202020204" pitchFamily="34" charset="0"/>
+              <a:buChar char="•"/>
+            </a:pPr>
+            <a:r>
+              <a:rPr lang="en-US" altLang="en-US" sz="1300">
+                <a:latin typeface="Arial" panose="020B0604020202020204" pitchFamily="34" charset="0"/>
+              </a:rPr>
+              <a:t>Əgər </a:t>
+            </a:r>
+            <a:r>
+              <a:rPr lang="en-US" altLang="en-US" sz="1300" b="1">
+                <a:latin typeface="Arial" panose="020B0604020202020204" pitchFamily="34" charset="0"/>
+              </a:rPr>
+              <a:t>$categories </a:t>
+            </a:r>
+            <a:r>
+              <a:rPr lang="en-US" altLang="en-US" sz="1300">
+                <a:latin typeface="Arial" panose="020B0604020202020204" pitchFamily="34" charset="0"/>
+              </a:rPr>
+              <a:t>yalnız </a:t>
+            </a:r>
+            <a:r>
+              <a:rPr lang="en-US" altLang="en-US" sz="1300" b="1">
+                <a:latin typeface="Arial" panose="020B0604020202020204" pitchFamily="34" charset="0"/>
+              </a:rPr>
+              <a:t>menu.blade.php </a:t>
+            </a:r>
+            <a:r>
+              <a:rPr lang="en-US" altLang="en-US" sz="1300">
+                <a:latin typeface="Arial" panose="020B0604020202020204" pitchFamily="34" charset="0"/>
+              </a:rPr>
+              <a:t>üçün lazımdır → </a:t>
+            </a:r>
+            <a:r>
+              <a:rPr lang="en-US" altLang="en-US" sz="1300" b="1">
+                <a:latin typeface="Arial" panose="020B0604020202020204" pitchFamily="34" charset="0"/>
+              </a:rPr>
+              <a:t>View Composer (#2) </a:t>
+            </a:r>
+            <a:r>
+              <a:rPr lang="en-US" altLang="en-US" sz="1300">
+                <a:latin typeface="Arial" panose="020B0604020202020204" pitchFamily="34" charset="0"/>
+              </a:rPr>
+              <a:t>istifadə et.</a:t>
+            </a:r>
+          </a:p>
+          <a:p>
+            <a:pPr marL="285750" indent="-285750">
+              <a:lnSpc>
+                <a:spcPct val="150000"/>
+              </a:lnSpc>
+              <a:buFont typeface="Arial" panose="020B0604020202020204" pitchFamily="34" charset="0"/>
+              <a:buChar char="•"/>
+            </a:pPr>
+            <a:endParaRPr lang="en-US" altLang="en-US" sz="1300">
+              <a:latin typeface="Arial" panose="020B0604020202020204" pitchFamily="34" charset="0"/>
+            </a:endParaRPr>
+          </a:p>
+          <a:p>
+            <a:pPr marL="285750" indent="-285750">
+              <a:lnSpc>
+                <a:spcPct val="150000"/>
+              </a:lnSpc>
+              <a:buFont typeface="Arial" panose="020B0604020202020204" pitchFamily="34" charset="0"/>
+              <a:buChar char="•"/>
+            </a:pPr>
+            <a:r>
+              <a:rPr lang="en-US" altLang="en-US" sz="1300">
+                <a:latin typeface="Arial" panose="020B0604020202020204" pitchFamily="34" charset="0"/>
+              </a:rPr>
+              <a:t>Əgər sadəcə bir səhifədə lazımdırsa → </a:t>
+            </a:r>
+            <a:r>
+              <a:rPr lang="en-US" altLang="en-US" sz="1300" b="1">
+                <a:latin typeface="Arial" panose="020B0604020202020204" pitchFamily="34" charset="0"/>
+              </a:rPr>
+              <a:t>Controller</a:t>
+            </a:r>
+            <a:r>
+              <a:rPr lang="en-US" altLang="en-US" sz="1300">
+                <a:latin typeface="Arial" panose="020B0604020202020204" pitchFamily="34" charset="0"/>
+              </a:rPr>
+              <a:t>-dən (#1) göndər.</a:t>
+            </a:r>
+          </a:p>
+          <a:p>
+            <a:pPr marL="285750" indent="-285750">
+              <a:lnSpc>
+                <a:spcPct val="150000"/>
+              </a:lnSpc>
+              <a:buFont typeface="Arial" panose="020B0604020202020204" pitchFamily="34" charset="0"/>
+              <a:buChar char="•"/>
+            </a:pPr>
+            <a:endParaRPr lang="en-US" altLang="en-US" sz="1300">
+              <a:latin typeface="Arial" panose="020B0604020202020204" pitchFamily="34" charset="0"/>
+            </a:endParaRPr>
+          </a:p>
+          <a:p>
+            <a:pPr marL="285750" indent="-285750">
+              <a:lnSpc>
+                <a:spcPct val="150000"/>
+              </a:lnSpc>
+              <a:buFont typeface="Arial" panose="020B0604020202020204" pitchFamily="34" charset="0"/>
+              <a:buChar char="•"/>
+            </a:pPr>
+            <a:r>
+              <a:rPr lang="en-US" altLang="en-US" sz="1300">
+                <a:latin typeface="Arial" panose="020B0604020202020204" pitchFamily="34" charset="0"/>
+              </a:rPr>
+              <a:t>Əgər hər yerdə istifadə olunacaqsa → </a:t>
+            </a:r>
+            <a:r>
+              <a:rPr lang="en-US" altLang="en-US" sz="1300" b="1">
+                <a:latin typeface="Arial" panose="020B0604020202020204" pitchFamily="34" charset="0"/>
+              </a:rPr>
+              <a:t>View::share </a:t>
+            </a:r>
+            <a:r>
+              <a:rPr lang="en-US" altLang="en-US" sz="1300">
+                <a:latin typeface="Arial" panose="020B0604020202020204" pitchFamily="34" charset="0"/>
+              </a:rPr>
+              <a:t>(#3).</a:t>
+            </a:r>
+          </a:p>
+          <a:p>
+            <a:pPr>
+              <a:lnSpc>
+                <a:spcPct val="150000"/>
+              </a:lnSpc>
+              <a:buNone/>
+            </a:pPr>
+            <a:endParaRPr kumimoji="0" lang="en-US" altLang="en-US" sz="1300" b="0" i="0" u="none" strike="noStrike" cap="none" normalizeH="0" baseline="0">
+              <a:ln>
+                <a:noFill/>
+              </a:ln>
+              <a:solidFill>
+                <a:schemeClr val="tx1"/>
+              </a:solidFill>
+              <a:effectLst/>
+              <a:latin typeface="Arial" panose="020B0604020202020204" pitchFamily="34" charset="0"/>
+            </a:endParaRPr>
+          </a:p>
+          <a:p>
+            <a:pPr>
+              <a:lnSpc>
+                <a:spcPct val="150000"/>
+              </a:lnSpc>
+              <a:buNone/>
+            </a:pPr>
+            <a:endParaRPr lang="en-US" altLang="en-US" sz="1300">
+              <a:latin typeface="Arial" panose="020B0604020202020204" pitchFamily="34" charset="0"/>
+            </a:endParaRPr>
+          </a:p>
+          <a:p>
+            <a:pPr>
+              <a:lnSpc>
+                <a:spcPct val="150000"/>
+              </a:lnSpc>
+              <a:buNone/>
+            </a:pPr>
+            <a:endParaRPr kumimoji="0" lang="en-US" altLang="en-US" sz="1300" b="0" i="0" u="none" strike="noStrike" cap="none" normalizeH="0" baseline="0">
+              <a:ln>
+                <a:noFill/>
+              </a:ln>
+              <a:solidFill>
+                <a:schemeClr val="tx1"/>
+              </a:solidFill>
+              <a:effectLst/>
+              <a:latin typeface="Arial" panose="020B0604020202020204" pitchFamily="34" charset="0"/>
+            </a:endParaRPr>
+          </a:p>
+        </p:txBody>
+      </p:sp>
+    </p:spTree>
+    <p:extLst>
+      <p:ext uri="{BB962C8B-B14F-4D97-AF65-F5344CB8AC3E}">
+        <p14:creationId xmlns:p14="http://schemas.microsoft.com/office/powerpoint/2010/main" val="3095838342"/>
+      </p:ext>
+    </p:extLst>
+  </p:cSld>
+  <p:clrMapOvr>
+    <a:masterClrMapping/>
+  </p:clrMapOvr>
+</p:sld>
+</file>
+
+<file path=ppt/slides/slide9.xml><?xml version="1.0" encoding="utf-8"?>
+<p:sld xmlns:a="http://schemas.openxmlformats.org/drawingml/2006/main" xmlns:r="http://schemas.openxmlformats.org/officeDocument/2006/relationships" xmlns:p="http://schemas.openxmlformats.org/presentationml/2006/main">
+  <p:cSld>
+    <p:spTree>
+      <p:nvGrpSpPr>
+        <p:cNvPr id="1" name="">
+          <a:extLst>
+            <a:ext uri="{FF2B5EF4-FFF2-40B4-BE49-F238E27FC236}">
+              <a16:creationId xmlns:a16="http://schemas.microsoft.com/office/drawing/2014/main" id="{AD80ED3B-A377-7AAE-472E-16FBD25332C6}"/>
+            </a:ext>
+          </a:extLst>
+        </p:cNvPr>
+        <p:cNvGrpSpPr/>
+        <p:nvPr/>
+      </p:nvGrpSpPr>
+      <p:grpSpPr>
+        <a:xfrm>
+          <a:off x="0" y="0"/>
+          <a:ext cx="0" cy="0"/>
+          <a:chOff x="0" y="0"/>
+          <a:chExt cx="0" cy="0"/>
+        </a:xfrm>
+      </p:grpSpPr>
+      <p:sp>
+        <p:nvSpPr>
+          <p:cNvPr id="3" name="TextBox 2">
+            <a:extLst>
+              <a:ext uri="{FF2B5EF4-FFF2-40B4-BE49-F238E27FC236}">
+                <a16:creationId xmlns:a16="http://schemas.microsoft.com/office/drawing/2014/main" id="{BC144A5E-A4A3-A56B-A50B-6009A3504479}"/>
+              </a:ext>
+            </a:extLst>
+          </p:cNvPr>
+          <p:cNvSpPr txBox="1"/>
+          <p:nvPr/>
+        </p:nvSpPr>
+        <p:spPr>
+          <a:xfrm>
+            <a:off x="217714" y="255046"/>
             <a:ext cx="11756571" cy="355354"/>
           </a:xfrm>
           <a:prstGeom prst="rect">
@@ -3541,25 +6208,58 @@
               <a:buNone/>
             </a:pPr>
             <a:r>
-              <a:rPr kumimoji="0" lang="en-US" altLang="en-US" sz="1300" b="0" i="0" u="none" strike="noStrike" cap="none" normalizeH="0" baseline="0">
-                <a:ln>
-                  <a:noFill/>
-                </a:ln>
-                <a:solidFill>
-                  <a:schemeClr val="tx1"/>
-                </a:solidFill>
-                <a:effectLst/>
-                <a:latin typeface="Arial" panose="020B0604020202020204" pitchFamily="34" charset="0"/>
-              </a:rPr>
-              <a:t>.</a:t>
-            </a:r>
-          </a:p>
-        </p:txBody>
-      </p:sp>
+              <a:rPr lang="en-US" altLang="en-US" sz="1300">
+                <a:latin typeface="Arial" panose="020B0604020202020204" pitchFamily="34" charset="0"/>
+              </a:rPr>
+              <a:t>resources\views\frontend\layouts\menu.blade.php</a:t>
+            </a:r>
+            <a:endParaRPr kumimoji="0" lang="en-US" altLang="en-US" sz="1300" b="0" i="0" u="none" strike="noStrike" cap="none" normalizeH="0" baseline="0">
+              <a:ln>
+                <a:noFill/>
+              </a:ln>
+              <a:solidFill>
+                <a:schemeClr val="tx1"/>
+              </a:solidFill>
+              <a:effectLst/>
+              <a:latin typeface="Arial" panose="020B0604020202020204" pitchFamily="34" charset="0"/>
+            </a:endParaRPr>
+          </a:p>
+        </p:txBody>
+      </p:sp>
+      <p:pic>
+        <p:nvPicPr>
+          <p:cNvPr id="4" name="Picture 3">
+            <a:extLst>
+              <a:ext uri="{FF2B5EF4-FFF2-40B4-BE49-F238E27FC236}">
+                <a16:creationId xmlns:a16="http://schemas.microsoft.com/office/drawing/2014/main" id="{A84E98E0-ABD1-1BB2-8FD8-5B46A2234DB8}"/>
+              </a:ext>
+            </a:extLst>
+          </p:cNvPr>
+          <p:cNvPicPr>
+            <a:picLocks noChangeAspect="1"/>
+          </p:cNvPicPr>
+          <p:nvPr/>
+        </p:nvPicPr>
+        <p:blipFill>
+          <a:blip r:embed="rId2"/>
+          <a:stretch>
+            <a:fillRect/>
+          </a:stretch>
+        </p:blipFill>
+        <p:spPr>
+          <a:xfrm>
+            <a:off x="4416862" y="0"/>
+            <a:ext cx="7775138" cy="6858000"/>
+          </a:xfrm>
+          <a:prstGeom prst="rect">
+            <a:avLst/>
+          </a:prstGeom>
+        </p:spPr>
+      </p:pic>
     </p:spTree>
     <p:extLst>
       <p:ext uri="{BB962C8B-B14F-4D97-AF65-F5344CB8AC3E}">
-        <p14:creationId xmlns:p14="http://schemas.microsoft.com/office/powerpoint/2010/main" val="3095838342"/>
+        <p14:creationId xmlns:p14="http://schemas.microsoft.com/office/powerpoint/2010/main" val="1499001703"/>
       </p:ext>
     </p:extLst>
   </p:cSld>

</xml_diff>